<commit_message>
Add prototype link to submission materials
</commit_message>
<xml_diff>
--- a/Product Docs/Submission/InvestigateIQ_Product_Presentation.pptx
+++ b/Product Docs/Submission/InvestigateIQ_Product_Presentation.pptx
@@ -4,6 +4,9 @@
   <p:sldMasterIdLst>
     <p:sldMasterId id="2147483648" r:id="rId1"/>
   </p:sldMasterIdLst>
+  <p:notesMasterIdLst>
+    <p:notesMasterId r:id="rId14"/>
+  </p:notesMasterIdLst>
   <p:sldIdLst>
     <p:sldId id="256" r:id="rId2"/>
     <p:sldId id="257" r:id="rId3"/>
@@ -18,9 +21,6 @@
     <p:sldId id="266" r:id="rId12"/>
     <p:sldId id="267" r:id="rId13"/>
   </p:sldIdLst>
-  <p:notesMasterIdLst>
-    <p:notesMasterId r:id="rId14"/>
-  </p:notesMasterIdLst>
   <p:sldSz cx="12192000" cy="6858000"/>
   <p:notesSz cx="6858000" cy="12192000"/>
   <p:defaultTextStyle>
@@ -115,6 +115,11 @@
       </a:defRPr>
     </a:lvl9pPr>
   </p:defaultTextStyle>
+  <p:extLst>
+    <p:ext uri="{EFAFB233-063F-42B5-8137-9DF3F51BA10A}">
+      <p15:sldGuideLst xmlns:p15="http://schemas.microsoft.com/office/powerpoint/2012/main"/>
+    </p:ext>
+  </p:extLst>
 </p:presentation>
 </file>
 
@@ -140,234 +145,10 @@
           <a:chExt cx="0" cy="0"/>
         </a:xfrm>
       </p:grpSpPr>
-      <p:sp>
-        <p:nvSpPr>
-          <p:cNvPr id="2" name="Header Placeholder 1"/>
-          <p:cNvSpPr>
-            <a:spLocks noGrp="1"/>
-          </p:cNvSpPr>
-          <p:nvPr>
-            <p:ph type="hdr" sz="quarter"/>
-          </p:nvPr>
-        </p:nvSpPr>
-        <p:spPr>
-          <a:xfrm>
-            <a:off x="0" y="0"/>
-            <a:ext cx="2971800" cy="458788"/>
-          </a:xfrm>
-          <a:prstGeom prst="rect">
-            <a:avLst/>
-          </a:prstGeom>
-        </p:spPr>
-        <p:txBody>
-          <a:bodyPr vert="horz" lIns="91440" tIns="45720" rIns="91440" bIns="45720" rtlCol="0"/>
-          <a:lstStyle>
-            <a:lvl1pPr algn="l">
-              <a:defRPr sz="1200"/>
-            </a:lvl1pPr>
-          </a:lstStyle>
-          <a:p>
-            <a:endParaRPr lang="en-US"/>
-          </a:p>
-        </p:txBody>
-      </p:sp>
-      <p:sp>
-        <p:nvSpPr>
-          <p:cNvPr id="3" name="Date Placeholder 2"/>
-          <p:cNvSpPr>
-            <a:spLocks noGrp="1"/>
-          </p:cNvSpPr>
-          <p:nvPr>
-            <p:ph type="dt" idx="1"/>
-          </p:nvPr>
-        </p:nvSpPr>
-        <p:spPr>
-          <a:xfrm>
-            <a:off x="3884613" y="0"/>
-            <a:ext cx="2971800" cy="458788"/>
-          </a:xfrm>
-          <a:prstGeom prst="rect">
-            <a:avLst/>
-          </a:prstGeom>
-        </p:spPr>
-        <p:txBody>
-          <a:bodyPr vert="horz" lIns="91440" tIns="45720" rIns="91440" bIns="45720" rtlCol="0"/>
-          <a:lstStyle>
-            <a:lvl1pPr algn="r">
-              <a:defRPr sz="1200"/>
-            </a:lvl1pPr>
-          </a:lstStyle>
-          <a:p>
-            <a:fld id="{5282F153-3F37-0F45-9E97-73ACFA13230C}" type="datetimeFigureOut">
-              <a:rPr lang="en-US"/>
-              <a:t>7/23/19</a:t>
-            </a:fld>
-            <a:endParaRPr lang="en-US"/>
-          </a:p>
-        </p:txBody>
-      </p:sp>
-      <p:sp>
-        <p:nvSpPr>
-          <p:cNvPr id="4" name="Slide Image Placeholder 3"/>
-          <p:cNvSpPr>
-            <a:spLocks noGrp="1" noRot="1" noChangeAspect="1"/>
-          </p:cNvSpPr>
-          <p:nvPr>
-            <p:ph type="sldImg" idx="2"/>
-          </p:nvPr>
-        </p:nvSpPr>
-        <p:spPr>
-          <a:xfrm>
-            <a:off x="685800" y="1143000"/>
-            <a:ext cx="5486400" cy="3086100"/>
-          </a:xfrm>
-          <a:prstGeom prst="rect">
-            <a:avLst/>
-          </a:prstGeom>
-          <a:noFill/>
-          <a:ln w="12700">
-            <a:solidFill>
-              <a:prstClr val="black"/>
-            </a:solidFill>
-          </a:ln>
-        </p:spPr>
-        <p:txBody>
-          <a:bodyPr vert="horz" lIns="91440" tIns="45720" rIns="91440" bIns="45720" rtlCol="0" anchor="ctr"/>
-          <a:lstStyle/>
-          <a:p>
-            <a:endParaRPr lang="en-US"/>
-          </a:p>
-        </p:txBody>
-      </p:sp>
-      <p:sp>
-        <p:nvSpPr>
-          <p:cNvPr id="5" name="Notes Placeholder 4"/>
-          <p:cNvSpPr>
-            <a:spLocks noGrp="1"/>
-          </p:cNvSpPr>
-          <p:nvPr>
-            <p:ph type="body" sz="quarter" idx="3"/>
-          </p:nvPr>
-        </p:nvSpPr>
-        <p:spPr>
-          <a:xfrm>
-            <a:off x="685800" y="4400550"/>
-            <a:ext cx="5486400" cy="3600450"/>
-          </a:xfrm>
-          <a:prstGeom prst="rect">
-            <a:avLst/>
-          </a:prstGeom>
-        </p:spPr>
-        <p:txBody>
-          <a:bodyPr vert="horz" lIns="91440" tIns="45720" rIns="91440" bIns="45720" rtlCol="0"/>
-          <a:lstStyle/>
-          <a:p>
-            <a:pPr lvl="0"/>
-            <a:r>
-              <a:rPr lang="en-US"/>
-              <a:t>Click to edit Master text styles</a:t>
-            </a:r>
-          </a:p>
-          <a:p>
-            <a:pPr lvl="1"/>
-            <a:r>
-              <a:rPr lang="en-US"/>
-              <a:t>Second level</a:t>
-            </a:r>
-          </a:p>
-          <a:p>
-            <a:pPr lvl="2"/>
-            <a:r>
-              <a:rPr lang="en-US"/>
-              <a:t>Third level</a:t>
-            </a:r>
-          </a:p>
-          <a:p>
-            <a:pPr lvl="3"/>
-            <a:r>
-              <a:rPr lang="en-US"/>
-              <a:t>Fourth level</a:t>
-            </a:r>
-          </a:p>
-          <a:p>
-            <a:pPr lvl="4"/>
-            <a:r>
-              <a:rPr lang="en-US"/>
-              <a:t>Fifth level</a:t>
-            </a:r>
-          </a:p>
-        </p:txBody>
-      </p:sp>
-      <p:sp>
-        <p:nvSpPr>
-          <p:cNvPr id="6" name="Footer Placeholder 5"/>
-          <p:cNvSpPr>
-            <a:spLocks noGrp="1"/>
-          </p:cNvSpPr>
-          <p:nvPr>
-            <p:ph type="ftr" sz="quarter" idx="4"/>
-          </p:nvPr>
-        </p:nvSpPr>
-        <p:spPr>
-          <a:xfrm>
-            <a:off x="0" y="8685213"/>
-            <a:ext cx="2971800" cy="458787"/>
-          </a:xfrm>
-          <a:prstGeom prst="rect">
-            <a:avLst/>
-          </a:prstGeom>
-        </p:spPr>
-        <p:txBody>
-          <a:bodyPr vert="horz" lIns="91440" tIns="45720" rIns="91440" bIns="45720" rtlCol="0" anchor="b"/>
-          <a:lstStyle>
-            <a:lvl1pPr algn="l">
-              <a:defRPr sz="1200"/>
-            </a:lvl1pPr>
-          </a:lstStyle>
-          <a:p>
-            <a:endParaRPr lang="en-US"/>
-          </a:p>
-        </p:txBody>
-      </p:sp>
-      <p:sp>
-        <p:nvSpPr>
-          <p:cNvPr id="7" name="Slide Number Placeholder 6"/>
-          <p:cNvSpPr>
-            <a:spLocks noGrp="1"/>
-          </p:cNvSpPr>
-          <p:nvPr>
-            <p:ph type="sldNum" sz="quarter" idx="5"/>
-          </p:nvPr>
-        </p:nvSpPr>
-        <p:spPr>
-          <a:xfrm>
-            <a:off x="3884613" y="8685213"/>
-            <a:ext cx="2971800" cy="458787"/>
-          </a:xfrm>
-          <a:prstGeom prst="rect">
-            <a:avLst/>
-          </a:prstGeom>
-        </p:spPr>
-        <p:txBody>
-          <a:bodyPr vert="horz" lIns="91440" tIns="45720" rIns="91440" bIns="45720" rtlCol="0" anchor="b"/>
-          <a:lstStyle>
-            <a:lvl1pPr algn="r">
-              <a:defRPr sz="1200"/>
-            </a:lvl1pPr>
-          </a:lstStyle>
-          <a:p>
-            <a:fld id="{CE5E9CC1-C706-0F49-92D6-E571CC5EEA8F}" type="slidenum">
-              <a:rPr lang="en-US"/>
-              <a:t>‹#›</a:t>
-            </a:fld>
-            <a:endParaRPr lang="en-US"/>
-          </a:p>
-        </p:txBody>
-      </p:sp>
     </p:spTree>
     <p:extLst>
       <p:ext uri="{BB962C8B-B14F-4D97-AF65-F5344CB8AC3E}">
-        <p14:creationId xmlns:p14="http://schemas.microsoft.com/office/powerpoint/2010/main" val="1024086991"/>
+        <p14:creationId xmlns:p14="http://schemas.microsoft.com/office/powerpoint/2010/main" val="2898917953"/>
       </p:ext>
     </p:extLst>
   </p:cSld>
@@ -515,7 +296,6 @@
               <a:rPr lang="en-US" dirty="0"/>
               <a:t>Soumya opens in 25 seconds. State that this is a fictional AML learning product. The deck uses 5 minutes 35 seconds, then the demo and questions share the remainder of the 15-minute session; FAQ slides are appendix material only when asked.</a:t>
             </a:r>
-            <a:endParaRPr lang="en-US" dirty="0"/>
           </a:p>
         </p:txBody>
       </p:sp>
@@ -603,7 +383,6 @@
               <a:rPr lang="en-US" dirty="0"/>
               <a:t>Appendix only—do not present unless asked. Soumya can state: the data is fictional; retrieval is lexical FTS5/BM25 over scoped local text; citations are review pointers, not proof.</a:t>
             </a:r>
-            <a:endParaRPr lang="en-US" dirty="0"/>
           </a:p>
         </p:txBody>
       </p:sp>
@@ -691,7 +470,6 @@
               <a:rPr lang="en-US" dirty="0"/>
               <a:t>Appendix only—do not present unless asked. Do not say the validator eliminates hallucination. Say it reduces specific risks and cannot guarantee factual truth.</a:t>
             </a:r>
-            <a:endParaRPr lang="en-US" dirty="0"/>
           </a:p>
         </p:txBody>
       </p:sp>
@@ -779,7 +557,6 @@
               <a:rPr lang="en-US" dirty="0"/>
               <a:t>Appendix only—do not present unless asked. State clearly that the Admin passcode is not disclosed, the demo is not RBAC, and ROI is a pilot measurement framework rather than a financial result.</a:t>
             </a:r>
-            <a:endParaRPr lang="en-US" dirty="0"/>
           </a:p>
         </p:txBody>
       </p:sp>
@@ -867,7 +644,6 @@
               <a:rPr lang="en-US" dirty="0"/>
               <a:t>Soumya uses 35 seconds. Read the statement, selected track, and non-goals. Introduce the team in the displayed order and say that Soumya presents while Laxman is the backup.</a:t>
             </a:r>
-            <a:endParaRPr lang="en-US" dirty="0"/>
           </a:p>
         </p:txBody>
       </p:sp>
@@ -955,7 +731,6 @@
               <a:rPr lang="en-US" dirty="0"/>
               <a:t>Soumya uses 30 seconds. Move left to right through the flow. Emphasize human decision ownership and separate Compliance review.</a:t>
             </a:r>
-            <a:endParaRPr lang="en-US" dirty="0"/>
           </a:p>
         </p:txBody>
       </p:sp>
@@ -1043,7 +818,6 @@
               <a:rPr lang="en-US" dirty="0"/>
               <a:t>Soumya uses 40 seconds. Define evidence confidence as deterministic support coverage. It is not a risk score, probability of crime, legality assessment, or recommended outcome.</a:t>
             </a:r>
-            <a:endParaRPr lang="en-US" dirty="0"/>
           </a:p>
         </p:txBody>
       </p:sp>
@@ -1131,7 +905,6 @@
               <a:rPr lang="en-US" dirty="0"/>
               <a:t>Soumya uses 55 seconds. OKF is Open Knowledge Format: a source record with stable metadata and body text. Explain C0 metadata and two-sentence chunks, then local SQLite FTS5 keyword search and BM25 ranking. Say retrieval finds text; it does not prove truth.</a:t>
             </a:r>
-            <a:endParaRPr lang="en-US" dirty="0"/>
           </a:p>
         </p:txBody>
       </p:sp>
@@ -1219,7 +992,6 @@
               <a:rPr lang="en-US" dirty="0"/>
               <a:t>Soumya uses 55 seconds. Point to the upper row first: a selected case loads stored fictional evidence, the specialist components build structured inputs, the Summary Agent optionally drafts, the validator checks selected claims, and a human records the action. Then point to the lower row: OKF guidance is chunked, FTS5/BM25 retrieves lexical matches, and exact cited chunks return to the report. Say clearly that retrieval is not proof, the validator reduces selected risks but cannot guarantee truth, and no action is automated.</a:t>
             </a:r>
-            <a:endParaRPr lang="en-US" dirty="0"/>
           </a:p>
         </p:txBody>
       </p:sp>
@@ -1307,7 +1079,6 @@
               <a:rPr lang="en-US" dirty="0"/>
               <a:t>Soumya uses 45 seconds to explain the demo plan, then performs it. Start with a documented closed case to show evidence access, then use the open/escalated case for the investigation. Do not submit an investigator or Compliance action, create intake data, reset decisions, or reveal an Admin passcode. Speak only about what is under the pointer.</a:t>
             </a:r>
-            <a:endParaRPr lang="en-US" dirty="0"/>
           </a:p>
         </p:txBody>
       </p:sp>
@@ -1395,7 +1166,6 @@
               <a:rPr lang="en-US" dirty="0"/>
               <a:t>Soumya uses 50 seconds. Say this is an ROI measurement framework, not an invented financial result. Name the four value levers and future sequence. A real ROI needs a baseline, approved costs, and verified pilot results.</a:t>
             </a:r>
-            <a:endParaRPr lang="en-US" dirty="0"/>
           </a:p>
         </p:txBody>
       </p:sp>
@@ -1483,7 +1253,6 @@
               <a:rPr lang="en-US" dirty="0"/>
               <a:t>Show this slide after the live demo. Soumya closes in 15 seconds and uses the FAQ appendix only if a relevant question is asked. Questions, demo, and slides all fit within the 15-minute session; no separate Q&amp;A allocation is assumed.</a:t>
             </a:r>
-            <a:endParaRPr lang="en-US" dirty="0"/>
           </a:p>
         </p:txBody>
       </p:sp>
@@ -1556,6 +1325,11 @@
 <file path=ppt/slideMasters/slideMaster1.xml><?xml version="1.0" encoding="utf-8"?>
 <p:sldMaster xmlns:a="http://schemas.openxmlformats.org/drawingml/2006/main" xmlns:r="http://schemas.openxmlformats.org/officeDocument/2006/relationships" xmlns:p="http://schemas.openxmlformats.org/presentationml/2006/main">
   <p:cSld>
+    <p:bg>
+      <p:bgRef idx="1001">
+        <a:schemeClr val="bg1"/>
+      </p:bgRef>
+    </p:bg>
     <p:spTree>
       <p:nvGrpSpPr>
         <p:cNvPr id="1" name=""/>
@@ -1838,6 +1612,7 @@
         <a:solidFill>
           <a:srgbClr val="0B1F3A"/>
         </a:solidFill>
+        <a:effectLst/>
       </p:bgPr>
     </p:bg>
     <p:spTree>
@@ -1856,14 +1631,14 @@
       </p:grpSpPr>
       <p:pic>
         <p:nvPicPr>
-          <p:cNvPr id="2" name="Image 0" descr="C:\D\IIT Mumbai\Capstone Blueprint\assets\walkthrough_screens\2026_home_guest.png">    </p:cNvPr>
+          <p:cNvPr id="2" name="Image 0" descr="C:\D\IIT Mumbai\Capstone Blueprint\assets\walkthrough_screens\2026_home_guest.png"/>
           <p:cNvPicPr>
             <a:picLocks noChangeAspect="1"/>
           </p:cNvPicPr>
           <p:nvPr/>
         </p:nvPicPr>
         <p:blipFill>
-          <a:blip r:embed="rId1">
+          <a:blip r:embed="rId3">
             <a:alphaModFix amt="79000"/>
           </a:blip>
           <a:stretch>
@@ -1908,6 +1683,13 @@
             <a:prstDash val="solid"/>
           </a:ln>
         </p:spPr>
+        <p:txBody>
+          <a:bodyPr/>
+          <a:lstStyle/>
+          <a:p>
+            <a:endParaRPr lang="en-IN"/>
+          </a:p>
+        </p:txBody>
       </p:sp>
       <p:sp>
         <p:nvSpPr>
@@ -1917,7 +1699,7 @@
         </p:nvSpPr>
         <p:spPr>
           <a:xfrm>
-            <a:off x="676656" y="694944"/>
+            <a:off x="676656" y="657620"/>
             <a:ext cx="1737360" cy="292608"/>
           </a:xfrm>
           <a:prstGeom prst="roundRect">
@@ -1937,6 +1719,13 @@
             <a:prstDash val="solid"/>
           </a:ln>
         </p:spPr>
+        <p:txBody>
+          <a:bodyPr/>
+          <a:lstStyle/>
+          <a:p>
+            <a:endParaRPr lang="en-IN"/>
+          </a:p>
+        </p:txBody>
       </p:sp>
       <p:sp>
         <p:nvSpPr>
@@ -1957,11 +1746,11 @@
         </p:spPr>
         <p:txBody>
           <a:bodyPr wrap="square" lIns="0" tIns="0" rIns="0" bIns="0" rtlCol="0" anchor="ctr">
-            <a:normAutofit/>
-          </a:bodyPr>
-          <a:lstStyle/>
-          <a:p>
-            <a:pPr algn="ctr" indent="0" marL="0">
+            <a:normAutofit lnSpcReduction="10000"/>
+          </a:bodyPr>
+          <a:lstStyle/>
+          <a:p>
+            <a:pPr marL="0" indent="0" algn="ctr">
               <a:buNone/>
             </a:pPr>
             <a:r>
@@ -1998,11 +1787,11 @@
         </p:spPr>
         <p:txBody>
           <a:bodyPr wrap="square" lIns="0" tIns="0" rIns="0" bIns="0" rtlCol="0" anchor="ctr">
-            <a:normAutofit/>
-          </a:bodyPr>
-          <a:lstStyle/>
-          <a:p>
-            <a:pPr algn="l" indent="0" marL="0">
+            <a:normAutofit fontScale="92500" lnSpcReduction="10000"/>
+          </a:bodyPr>
+          <a:lstStyle/>
+          <a:p>
+            <a:pPr marL="0" indent="0" algn="l">
               <a:buNone/>
             </a:pPr>
             <a:r>
@@ -2039,11 +1828,11 @@
         </p:spPr>
         <p:txBody>
           <a:bodyPr wrap="square" lIns="0" tIns="0" rIns="0" bIns="0" rtlCol="0" anchor="ctr">
-            <a:normAutofit/>
-          </a:bodyPr>
-          <a:lstStyle/>
-          <a:p>
-            <a:pPr algn="l" indent="0" marL="0">
+            <a:normAutofit fontScale="92500"/>
+          </a:bodyPr>
+          <a:lstStyle/>
+          <a:p>
+            <a:pPr marL="0" indent="0" algn="l">
               <a:buNone/>
             </a:pPr>
             <a:r>
@@ -2069,8 +1858,8 @@
         </p:nvSpPr>
         <p:spPr>
           <a:xfrm>
-            <a:off x="704088" y="2670048"/>
-            <a:ext cx="4937760" cy="566928"/>
+            <a:off x="704087" y="2670048"/>
+            <a:ext cx="5472777" cy="1351446"/>
           </a:xfrm>
           <a:prstGeom prst="rect">
             <a:avLst/>
@@ -2080,25 +1869,77 @@
         </p:spPr>
         <p:txBody>
           <a:bodyPr wrap="square" lIns="0" tIns="0" rIns="0" bIns="0" rtlCol="0" anchor="t">
-            <a:normAutofit/>
-          </a:bodyPr>
-          <a:lstStyle/>
-          <a:p>
-            <a:pPr algn="l" indent="0" marL="0">
-              <a:buNone/>
-            </a:pPr>
-            <a:r>
-              <a:rPr lang="en-US" sz="1800" dirty="0">
+            <a:noAutofit/>
+          </a:bodyPr>
+          <a:lstStyle/>
+          <a:p>
+            <a:pPr marL="0" indent="0" algn="l">
+              <a:buNone/>
+            </a:pPr>
+            <a:r>
+              <a:rPr lang="en-US" sz="1400" dirty="0">
                 <a:solidFill>
                   <a:srgbClr val="DDEBFF"/>
                 </a:solidFill>
-                <a:latin typeface="Arial" pitchFamily="34" charset="0"/>
-                <a:ea typeface="Arial" pitchFamily="34" charset="-122"/>
-                <a:cs typeface="Arial" pitchFamily="34" charset="-120"/>
+                <a:latin typeface="Calibri" panose="020F0502020204030204" pitchFamily="34" charset="0"/>
+                <a:ea typeface="Calibri" panose="020F0502020204030204" pitchFamily="34" charset="0"/>
+                <a:cs typeface="Calibri" panose="020F0502020204030204" pitchFamily="34" charset="0"/>
               </a:rPr>
               <a:t>A transparent, AI-assisted workflow for fictional AML case investigations.</a:t>
             </a:r>
-            <a:endParaRPr lang="en-US" sz="1800" dirty="0"/>
+          </a:p>
+          <a:p>
+            <a:pPr marL="0" indent="0" algn="l">
+              <a:buNone/>
+            </a:pPr>
+            <a:endParaRPr lang="en-US" sz="1400" dirty="0">
+              <a:solidFill>
+                <a:srgbClr val="DDEBFF"/>
+              </a:solidFill>
+              <a:latin typeface="Calibri" panose="020F0502020204030204" pitchFamily="34" charset="0"/>
+              <a:ea typeface="Calibri" panose="020F0502020204030204" pitchFamily="34" charset="0"/>
+              <a:cs typeface="Calibri" panose="020F0502020204030204" pitchFamily="34" charset="0"/>
+            </a:endParaRPr>
+          </a:p>
+          <a:p>
+            <a:r>
+              <a:rPr lang="en-US" sz="1400" dirty="0">
+                <a:solidFill>
+                  <a:srgbClr val="DDEBFF"/>
+                </a:solidFill>
+                <a:latin typeface="Calibri" panose="020F0502020204030204" pitchFamily="34" charset="0"/>
+                <a:ea typeface="Calibri" panose="020F0502020204030204" pitchFamily="34" charset="0"/>
+                <a:cs typeface="Calibri" panose="020F0502020204030204" pitchFamily="34" charset="0"/>
+              </a:rPr>
+              <a:t>Prototype- </a:t>
+            </a:r>
+            <a:r>
+              <a:rPr lang="en-US" sz="1400" dirty="0">
+                <a:solidFill>
+                  <a:srgbClr val="DDEBFF"/>
+                </a:solidFill>
+                <a:latin typeface="Calibri" panose="020F0502020204030204" pitchFamily="34" charset="0"/>
+                <a:ea typeface="Calibri" panose="020F0502020204030204" pitchFamily="34" charset="0"/>
+                <a:cs typeface="Calibri" panose="020F0502020204030204" pitchFamily="34" charset="0"/>
+                <a:hlinkClick r:id="rId4"/>
+              </a:rPr>
+              <a:t>https://investigateiq-app-production.up.railway.app/</a:t>
+            </a:r>
+            <a:endParaRPr lang="en-US" sz="1400" dirty="0">
+              <a:solidFill>
+                <a:srgbClr val="DDEBFF"/>
+              </a:solidFill>
+              <a:latin typeface="Calibri" panose="020F0502020204030204" pitchFamily="34" charset="0"/>
+              <a:ea typeface="Calibri" panose="020F0502020204030204" pitchFamily="34" charset="0"/>
+              <a:cs typeface="Calibri" panose="020F0502020204030204" pitchFamily="34" charset="0"/>
+            </a:endParaRPr>
+          </a:p>
+          <a:p>
+            <a:endParaRPr lang="en-US" sz="1400" dirty="0">
+              <a:latin typeface="Calibri" panose="020F0502020204030204" pitchFamily="34" charset="0"/>
+              <a:ea typeface="Calibri" panose="020F0502020204030204" pitchFamily="34" charset="0"/>
+              <a:cs typeface="Calibri" panose="020F0502020204030204" pitchFamily="34" charset="0"/>
+            </a:endParaRPr>
           </a:p>
         </p:txBody>
       </p:sp>
@@ -2121,11 +1962,11 @@
         </p:spPr>
         <p:txBody>
           <a:bodyPr wrap="square" lIns="0" tIns="0" rIns="0" bIns="0" rtlCol="0" anchor="ctr">
-            <a:normAutofit/>
-          </a:bodyPr>
-          <a:lstStyle/>
-          <a:p>
-            <a:pPr algn="l" indent="0" marL="0">
+            <a:normAutofit lnSpcReduction="10000"/>
+          </a:bodyPr>
+          <a:lstStyle/>
+          <a:p>
+            <a:pPr marL="0" indent="0" algn="l">
               <a:buNone/>
             </a:pPr>
             <a:r>
@@ -2162,11 +2003,11 @@
         </p:spPr>
         <p:txBody>
           <a:bodyPr wrap="square" lIns="0" tIns="0" rIns="0" bIns="0" rtlCol="0" anchor="ctr">
-            <a:normAutofit/>
-          </a:bodyPr>
-          <a:lstStyle/>
-          <a:p>
-            <a:pPr algn="l" indent="0" marL="0">
+            <a:normAutofit lnSpcReduction="10000"/>
+          </a:bodyPr>
+          <a:lstStyle/>
+          <a:p>
+            <a:pPr marL="0" indent="0" algn="l">
               <a:buNone/>
             </a:pPr>
             <a:r>
@@ -2207,7 +2048,7 @@
           </a:bodyPr>
           <a:lstStyle/>
           <a:p>
-            <a:pPr algn="l" indent="0" marL="0">
+            <a:pPr marL="0" indent="0" algn="l">
               <a:buNone/>
             </a:pPr>
             <a:r>
@@ -2248,7 +2089,7 @@
           </a:bodyPr>
           <a:lstStyle/>
           <a:p>
-            <a:pPr algn="r" indent="0" marL="0">
+            <a:pPr marL="0" indent="0" algn="r">
               <a:buNone/>
             </a:pPr>
             <a:r>
@@ -2271,7 +2112,7 @@
   <p:clrMapOvr>
     <a:masterClrMapping/>
   </p:clrMapOvr>
-  <p:transition spd="med" advClick="1">
+  <p:transition spd="med">
     <p:fade/>
   </p:transition>
 </p:sld>
@@ -2285,6 +2126,7 @@
         <a:solidFill>
           <a:srgbClr val="F6F9FE"/>
         </a:solidFill>
+        <a:effectLst/>
       </p:bgPr>
     </p:bg>
     <p:spTree>
@@ -2324,7 +2166,7 @@
           </a:bodyPr>
           <a:lstStyle/>
           <a:p>
-            <a:pPr algn="l" indent="0" marL="0">
+            <a:pPr marL="0" indent="0" algn="l">
               <a:buNone/>
             </a:pPr>
             <a:r>
@@ -2361,11 +2203,11 @@
         </p:spPr>
         <p:txBody>
           <a:bodyPr wrap="square" lIns="0" tIns="0" rIns="0" bIns="0" rtlCol="0" anchor="ctr">
-            <a:normAutofit/>
-          </a:bodyPr>
-          <a:lstStyle/>
-          <a:p>
-            <a:pPr algn="l" indent="0" marL="0">
+            <a:normAutofit lnSpcReduction="10000"/>
+          </a:bodyPr>
+          <a:lstStyle/>
+          <a:p>
+            <a:pPr marL="0" indent="0" algn="l">
               <a:buNone/>
             </a:pPr>
             <a:r>
@@ -2406,7 +2248,7 @@
           </a:bodyPr>
           <a:lstStyle/>
           <a:p>
-            <a:pPr algn="l" indent="0" marL="0">
+            <a:pPr marL="0" indent="0" algn="l">
               <a:buNone/>
             </a:pPr>
             <a:r>
@@ -2447,7 +2289,7 @@
           </a:bodyPr>
           <a:lstStyle/>
           <a:p>
-            <a:pPr algn="r" indent="0" marL="0">
+            <a:pPr marL="0" indent="0" algn="r">
               <a:buNone/>
             </a:pPr>
             <a:r>
@@ -2493,6 +2335,13 @@
             <a:prstDash val="solid"/>
           </a:ln>
         </p:spPr>
+        <p:txBody>
+          <a:bodyPr/>
+          <a:lstStyle/>
+          <a:p>
+            <a:endParaRPr lang="en-IN"/>
+          </a:p>
+        </p:txBody>
       </p:sp>
       <p:sp>
         <p:nvSpPr>
@@ -2513,11 +2362,11 @@
         </p:spPr>
         <p:txBody>
           <a:bodyPr wrap="square" lIns="0" tIns="0" rIns="0" bIns="0" rtlCol="0" anchor="ctr">
-            <a:normAutofit/>
-          </a:bodyPr>
-          <a:lstStyle/>
-          <a:p>
-            <a:pPr algn="l" indent="0" marL="0">
+            <a:normAutofit fontScale="92500" lnSpcReduction="20000"/>
+          </a:bodyPr>
+          <a:lstStyle/>
+          <a:p>
+            <a:pPr marL="0" indent="0" algn="l">
               <a:buNone/>
             </a:pPr>
             <a:r>
@@ -2558,7 +2407,7 @@
           </a:bodyPr>
           <a:lstStyle/>
           <a:p>
-            <a:pPr algn="l" indent="0" marL="0">
+            <a:pPr marL="0" indent="0" algn="l">
               <a:buNone/>
             </a:pPr>
             <a:r>
@@ -2604,6 +2453,13 @@
             <a:prstDash val="solid"/>
           </a:ln>
         </p:spPr>
+        <p:txBody>
+          <a:bodyPr/>
+          <a:lstStyle/>
+          <a:p>
+            <a:endParaRPr lang="en-IN"/>
+          </a:p>
+        </p:txBody>
       </p:sp>
       <p:sp>
         <p:nvSpPr>
@@ -2624,11 +2480,11 @@
         </p:spPr>
         <p:txBody>
           <a:bodyPr wrap="square" lIns="0" tIns="0" rIns="0" bIns="0" rtlCol="0" anchor="ctr">
-            <a:normAutofit/>
-          </a:bodyPr>
-          <a:lstStyle/>
-          <a:p>
-            <a:pPr algn="l" indent="0" marL="0">
+            <a:normAutofit fontScale="92500" lnSpcReduction="20000"/>
+          </a:bodyPr>
+          <a:lstStyle/>
+          <a:p>
+            <a:pPr marL="0" indent="0" algn="l">
               <a:buNone/>
             </a:pPr>
             <a:r>
@@ -2669,7 +2525,7 @@
           </a:bodyPr>
           <a:lstStyle/>
           <a:p>
-            <a:pPr algn="l" indent="0" marL="0">
+            <a:pPr marL="0" indent="0" algn="l">
               <a:buNone/>
             </a:pPr>
             <a:r>
@@ -2715,6 +2571,13 @@
             <a:prstDash val="solid"/>
           </a:ln>
         </p:spPr>
+        <p:txBody>
+          <a:bodyPr/>
+          <a:lstStyle/>
+          <a:p>
+            <a:endParaRPr lang="en-IN"/>
+          </a:p>
+        </p:txBody>
       </p:sp>
       <p:sp>
         <p:nvSpPr>
@@ -2735,11 +2598,11 @@
         </p:spPr>
         <p:txBody>
           <a:bodyPr wrap="square" lIns="0" tIns="0" rIns="0" bIns="0" rtlCol="0" anchor="ctr">
-            <a:normAutofit/>
-          </a:bodyPr>
-          <a:lstStyle/>
-          <a:p>
-            <a:pPr algn="l" indent="0" marL="0">
+            <a:normAutofit fontScale="92500" lnSpcReduction="20000"/>
+          </a:bodyPr>
+          <a:lstStyle/>
+          <a:p>
+            <a:pPr marL="0" indent="0" algn="l">
               <a:buNone/>
             </a:pPr>
             <a:r>
@@ -2780,7 +2643,7 @@
           </a:bodyPr>
           <a:lstStyle/>
           <a:p>
-            <a:pPr algn="l" indent="0" marL="0">
+            <a:pPr marL="0" indent="0" algn="l">
               <a:buNone/>
             </a:pPr>
             <a:r>
@@ -2803,7 +2666,7 @@
   <p:clrMapOvr>
     <a:masterClrMapping/>
   </p:clrMapOvr>
-  <p:transition spd="med" advClick="1">
+  <p:transition spd="med">
     <p:fade/>
   </p:transition>
 </p:sld>
@@ -2817,6 +2680,7 @@
         <a:solidFill>
           <a:srgbClr val="0B1F3A"/>
         </a:solidFill>
+        <a:effectLst/>
       </p:bgPr>
     </p:bg>
     <p:spTree>
@@ -2856,7 +2720,7 @@
           </a:bodyPr>
           <a:lstStyle/>
           <a:p>
-            <a:pPr algn="l" indent="0" marL="0">
+            <a:pPr marL="0" indent="0" algn="l">
               <a:buNone/>
             </a:pPr>
             <a:r>
@@ -2893,11 +2757,11 @@
         </p:spPr>
         <p:txBody>
           <a:bodyPr wrap="square" lIns="0" tIns="0" rIns="0" bIns="0" rtlCol="0" anchor="ctr">
-            <a:normAutofit/>
-          </a:bodyPr>
-          <a:lstStyle/>
-          <a:p>
-            <a:pPr algn="l" indent="0" marL="0">
+            <a:normAutofit lnSpcReduction="10000"/>
+          </a:bodyPr>
+          <a:lstStyle/>
+          <a:p>
+            <a:pPr marL="0" indent="0" algn="l">
               <a:buNone/>
             </a:pPr>
             <a:r>
@@ -2938,7 +2802,7 @@
           </a:bodyPr>
           <a:lstStyle/>
           <a:p>
-            <a:pPr algn="l" indent="0" marL="0">
+            <a:pPr marL="0" indent="0" algn="l">
               <a:buNone/>
             </a:pPr>
             <a:r>
@@ -2979,7 +2843,7 @@
           </a:bodyPr>
           <a:lstStyle/>
           <a:p>
-            <a:pPr algn="r" indent="0" marL="0">
+            <a:pPr marL="0" indent="0" algn="r">
               <a:buNone/>
             </a:pPr>
             <a:r>
@@ -3025,6 +2889,13 @@
             <a:prstDash val="solid"/>
           </a:ln>
         </p:spPr>
+        <p:txBody>
+          <a:bodyPr/>
+          <a:lstStyle/>
+          <a:p>
+            <a:endParaRPr lang="en-IN"/>
+          </a:p>
+        </p:txBody>
       </p:sp>
       <p:sp>
         <p:nvSpPr>
@@ -3045,11 +2916,11 @@
         </p:spPr>
         <p:txBody>
           <a:bodyPr wrap="square" lIns="0" tIns="0" rIns="0" bIns="0" rtlCol="0" anchor="ctr">
-            <a:normAutofit/>
-          </a:bodyPr>
-          <a:lstStyle/>
-          <a:p>
-            <a:pPr algn="l" indent="0" marL="0">
+            <a:normAutofit fontScale="92500" lnSpcReduction="20000"/>
+          </a:bodyPr>
+          <a:lstStyle/>
+          <a:p>
+            <a:pPr marL="0" indent="0" algn="l">
               <a:buNone/>
             </a:pPr>
             <a:r>
@@ -3090,7 +2961,7 @@
           </a:bodyPr>
           <a:lstStyle/>
           <a:p>
-            <a:pPr algn="l" indent="0" marL="0">
+            <a:pPr marL="0" indent="0" algn="l">
               <a:buNone/>
             </a:pPr>
             <a:r>
@@ -3136,6 +3007,13 @@
             <a:prstDash val="solid"/>
           </a:ln>
         </p:spPr>
+        <p:txBody>
+          <a:bodyPr/>
+          <a:lstStyle/>
+          <a:p>
+            <a:endParaRPr lang="en-IN"/>
+          </a:p>
+        </p:txBody>
       </p:sp>
       <p:sp>
         <p:nvSpPr>
@@ -3156,11 +3034,11 @@
         </p:spPr>
         <p:txBody>
           <a:bodyPr wrap="square" lIns="0" tIns="0" rIns="0" bIns="0" rtlCol="0" anchor="ctr">
-            <a:normAutofit/>
-          </a:bodyPr>
-          <a:lstStyle/>
-          <a:p>
-            <a:pPr algn="l" indent="0" marL="0">
+            <a:normAutofit fontScale="92500" lnSpcReduction="20000"/>
+          </a:bodyPr>
+          <a:lstStyle/>
+          <a:p>
+            <a:pPr marL="0" indent="0" algn="l">
               <a:buNone/>
             </a:pPr>
             <a:r>
@@ -3201,7 +3079,7 @@
           </a:bodyPr>
           <a:lstStyle/>
           <a:p>
-            <a:pPr algn="l" indent="0" marL="0">
+            <a:pPr marL="0" indent="0" algn="l">
               <a:buNone/>
             </a:pPr>
             <a:r>
@@ -3247,6 +3125,13 @@
             <a:prstDash val="solid"/>
           </a:ln>
         </p:spPr>
+        <p:txBody>
+          <a:bodyPr/>
+          <a:lstStyle/>
+          <a:p>
+            <a:endParaRPr lang="en-IN"/>
+          </a:p>
+        </p:txBody>
       </p:sp>
       <p:sp>
         <p:nvSpPr>
@@ -3267,11 +3152,11 @@
         </p:spPr>
         <p:txBody>
           <a:bodyPr wrap="square" lIns="0" tIns="0" rIns="0" bIns="0" rtlCol="0" anchor="ctr">
-            <a:normAutofit/>
-          </a:bodyPr>
-          <a:lstStyle/>
-          <a:p>
-            <a:pPr algn="l" indent="0" marL="0">
+            <a:normAutofit fontScale="92500" lnSpcReduction="20000"/>
+          </a:bodyPr>
+          <a:lstStyle/>
+          <a:p>
+            <a:pPr marL="0" indent="0" algn="l">
               <a:buNone/>
             </a:pPr>
             <a:r>
@@ -3312,7 +3197,7 @@
           </a:bodyPr>
           <a:lstStyle/>
           <a:p>
-            <a:pPr algn="l" indent="0" marL="0">
+            <a:pPr marL="0" indent="0" algn="l">
               <a:buNone/>
             </a:pPr>
             <a:r>
@@ -3335,7 +3220,7 @@
   <p:clrMapOvr>
     <a:masterClrMapping/>
   </p:clrMapOvr>
-  <p:transition spd="med" advClick="1">
+  <p:transition spd="med">
     <p:fade/>
   </p:transition>
 </p:sld>
@@ -3349,6 +3234,7 @@
         <a:solidFill>
           <a:srgbClr val="F6F9FE"/>
         </a:solidFill>
+        <a:effectLst/>
       </p:bgPr>
     </p:bg>
     <p:spTree>
@@ -3388,7 +3274,7 @@
           </a:bodyPr>
           <a:lstStyle/>
           <a:p>
-            <a:pPr algn="l" indent="0" marL="0">
+            <a:pPr marL="0" indent="0" algn="l">
               <a:buNone/>
             </a:pPr>
             <a:r>
@@ -3425,11 +3311,11 @@
         </p:spPr>
         <p:txBody>
           <a:bodyPr wrap="square" lIns="0" tIns="0" rIns="0" bIns="0" rtlCol="0" anchor="ctr">
-            <a:normAutofit/>
-          </a:bodyPr>
-          <a:lstStyle/>
-          <a:p>
-            <a:pPr algn="l" indent="0" marL="0">
+            <a:normAutofit lnSpcReduction="10000"/>
+          </a:bodyPr>
+          <a:lstStyle/>
+          <a:p>
+            <a:pPr marL="0" indent="0" algn="l">
               <a:buNone/>
             </a:pPr>
             <a:r>
@@ -3470,7 +3356,7 @@
           </a:bodyPr>
           <a:lstStyle/>
           <a:p>
-            <a:pPr algn="l" indent="0" marL="0">
+            <a:pPr marL="0" indent="0" algn="l">
               <a:buNone/>
             </a:pPr>
             <a:r>
@@ -3511,7 +3397,7 @@
           </a:bodyPr>
           <a:lstStyle/>
           <a:p>
-            <a:pPr algn="r" indent="0" marL="0">
+            <a:pPr marL="0" indent="0" algn="r">
               <a:buNone/>
             </a:pPr>
             <a:r>
@@ -3557,6 +3443,13 @@
             <a:prstDash val="solid"/>
           </a:ln>
         </p:spPr>
+        <p:txBody>
+          <a:bodyPr/>
+          <a:lstStyle/>
+          <a:p>
+            <a:endParaRPr lang="en-IN"/>
+          </a:p>
+        </p:txBody>
       </p:sp>
       <p:sp>
         <p:nvSpPr>
@@ -3577,11 +3470,11 @@
         </p:spPr>
         <p:txBody>
           <a:bodyPr wrap="square" lIns="0" tIns="0" rIns="0" bIns="0" rtlCol="0" anchor="ctr">
-            <a:normAutofit/>
-          </a:bodyPr>
-          <a:lstStyle/>
-          <a:p>
-            <a:pPr algn="l" indent="0" marL="0">
+            <a:normAutofit fontScale="92500" lnSpcReduction="20000"/>
+          </a:bodyPr>
+          <a:lstStyle/>
+          <a:p>
+            <a:pPr marL="0" indent="0" algn="l">
               <a:buNone/>
             </a:pPr>
             <a:r>
@@ -3622,7 +3515,7 @@
           </a:bodyPr>
           <a:lstStyle/>
           <a:p>
-            <a:pPr algn="l" indent="0" marL="0">
+            <a:pPr marL="0" indent="0" algn="l">
               <a:buNone/>
             </a:pPr>
             <a:r>
@@ -3668,6 +3561,13 @@
             <a:prstDash val="solid"/>
           </a:ln>
         </p:spPr>
+        <p:txBody>
+          <a:bodyPr/>
+          <a:lstStyle/>
+          <a:p>
+            <a:endParaRPr lang="en-IN"/>
+          </a:p>
+        </p:txBody>
       </p:sp>
       <p:sp>
         <p:nvSpPr>
@@ -3688,11 +3588,11 @@
         </p:spPr>
         <p:txBody>
           <a:bodyPr wrap="square" lIns="0" tIns="0" rIns="0" bIns="0" rtlCol="0" anchor="ctr">
-            <a:normAutofit/>
-          </a:bodyPr>
-          <a:lstStyle/>
-          <a:p>
-            <a:pPr algn="l" indent="0" marL="0">
+            <a:normAutofit fontScale="92500" lnSpcReduction="20000"/>
+          </a:bodyPr>
+          <a:lstStyle/>
+          <a:p>
+            <a:pPr marL="0" indent="0" algn="l">
               <a:buNone/>
             </a:pPr>
             <a:r>
@@ -3733,7 +3633,7 @@
           </a:bodyPr>
           <a:lstStyle/>
           <a:p>
-            <a:pPr algn="l" indent="0" marL="0">
+            <a:pPr marL="0" indent="0" algn="l">
               <a:buNone/>
             </a:pPr>
             <a:r>
@@ -3779,6 +3679,13 @@
             <a:prstDash val="solid"/>
           </a:ln>
         </p:spPr>
+        <p:txBody>
+          <a:bodyPr/>
+          <a:lstStyle/>
+          <a:p>
+            <a:endParaRPr lang="en-IN"/>
+          </a:p>
+        </p:txBody>
       </p:sp>
       <p:sp>
         <p:nvSpPr>
@@ -3799,11 +3706,11 @@
         </p:spPr>
         <p:txBody>
           <a:bodyPr wrap="square" lIns="0" tIns="0" rIns="0" bIns="0" rtlCol="0" anchor="ctr">
-            <a:normAutofit/>
-          </a:bodyPr>
-          <a:lstStyle/>
-          <a:p>
-            <a:pPr algn="l" indent="0" marL="0">
+            <a:normAutofit fontScale="85000" lnSpcReduction="10000"/>
+          </a:bodyPr>
+          <a:lstStyle/>
+          <a:p>
+            <a:pPr marL="0" indent="0" algn="l">
               <a:buNone/>
             </a:pPr>
             <a:r>
@@ -3844,7 +3751,7 @@
           </a:bodyPr>
           <a:lstStyle/>
           <a:p>
-            <a:pPr algn="l" indent="0" marL="0">
+            <a:pPr marL="0" indent="0" algn="l">
               <a:buNone/>
             </a:pPr>
             <a:r>
@@ -3867,7 +3774,7 @@
   <p:clrMapOvr>
     <a:masterClrMapping/>
   </p:clrMapOvr>
-  <p:transition spd="med" advClick="1">
+  <p:transition spd="med">
     <p:fade/>
   </p:transition>
 </p:sld>
@@ -3881,6 +3788,7 @@
         <a:solidFill>
           <a:srgbClr val="F6F9FE"/>
         </a:solidFill>
+        <a:effectLst/>
       </p:bgPr>
     </p:bg>
     <p:spTree>
@@ -3920,7 +3828,7 @@
           </a:bodyPr>
           <a:lstStyle/>
           <a:p>
-            <a:pPr algn="l" indent="0" marL="0">
+            <a:pPr marL="0" indent="0" algn="l">
               <a:buNone/>
             </a:pPr>
             <a:r>
@@ -3957,11 +3865,11 @@
         </p:spPr>
         <p:txBody>
           <a:bodyPr wrap="square" lIns="0" tIns="0" rIns="0" bIns="0" rtlCol="0" anchor="ctr">
-            <a:normAutofit/>
-          </a:bodyPr>
-          <a:lstStyle/>
-          <a:p>
-            <a:pPr algn="l" indent="0" marL="0">
+            <a:normAutofit lnSpcReduction="10000"/>
+          </a:bodyPr>
+          <a:lstStyle/>
+          <a:p>
+            <a:pPr marL="0" indent="0" algn="l">
               <a:buNone/>
             </a:pPr>
             <a:r>
@@ -4002,7 +3910,7 @@
           </a:bodyPr>
           <a:lstStyle/>
           <a:p>
-            <a:pPr algn="l" indent="0" marL="0">
+            <a:pPr marL="0" indent="0" algn="l">
               <a:buNone/>
             </a:pPr>
             <a:r>
@@ -4043,7 +3951,7 @@
           </a:bodyPr>
           <a:lstStyle/>
           <a:p>
-            <a:pPr algn="r" indent="0" marL="0">
+            <a:pPr marL="0" indent="0" algn="r">
               <a:buNone/>
             </a:pPr>
             <a:r>
@@ -4089,6 +3997,13 @@
             <a:prstDash val="solid"/>
           </a:ln>
         </p:spPr>
+        <p:txBody>
+          <a:bodyPr/>
+          <a:lstStyle/>
+          <a:p>
+            <a:endParaRPr lang="en-IN"/>
+          </a:p>
+        </p:txBody>
       </p:sp>
       <p:sp>
         <p:nvSpPr>
@@ -4109,11 +4024,11 @@
         </p:spPr>
         <p:txBody>
           <a:bodyPr wrap="square" lIns="0" tIns="0" rIns="0" bIns="0" rtlCol="0" anchor="ctr">
-            <a:normAutofit/>
-          </a:bodyPr>
-          <a:lstStyle/>
-          <a:p>
-            <a:pPr algn="ctr" indent="0" marL="0">
+            <a:normAutofit fontScale="92500" lnSpcReduction="20000"/>
+          </a:bodyPr>
+          <a:lstStyle/>
+          <a:p>
+            <a:pPr marL="0" indent="0" algn="ctr">
               <a:buNone/>
             </a:pPr>
             <a:r>
@@ -4159,6 +4074,13 @@
             <a:prstDash val="solid"/>
           </a:ln>
         </p:spPr>
+        <p:txBody>
+          <a:bodyPr/>
+          <a:lstStyle/>
+          <a:p>
+            <a:endParaRPr lang="en-IN"/>
+          </a:p>
+        </p:txBody>
       </p:sp>
       <p:sp>
         <p:nvSpPr>
@@ -4179,11 +4101,11 @@
         </p:spPr>
         <p:txBody>
           <a:bodyPr wrap="square" lIns="0" tIns="0" rIns="0" bIns="0" rtlCol="0" anchor="ctr">
-            <a:normAutofit/>
-          </a:bodyPr>
-          <a:lstStyle/>
-          <a:p>
-            <a:pPr algn="l" indent="0" marL="0">
+            <a:normAutofit fontScale="92500" lnSpcReduction="10000"/>
+          </a:bodyPr>
+          <a:lstStyle/>
+          <a:p>
+            <a:pPr marL="0" indent="0" algn="l">
               <a:buNone/>
             </a:pPr>
             <a:r>
@@ -4220,11 +4142,11 @@
         </p:spPr>
         <p:txBody>
           <a:bodyPr wrap="square" lIns="0" tIns="0" rIns="0" bIns="0" rtlCol="0" anchor="t">
-            <a:normAutofit/>
-          </a:bodyPr>
-          <a:lstStyle/>
-          <a:p>
-            <a:pPr algn="l" indent="0" marL="0">
+            <a:normAutofit fontScale="92500"/>
+          </a:bodyPr>
+          <a:lstStyle/>
+          <a:p>
+            <a:pPr marL="0" indent="0" algn="l">
               <a:buNone/>
             </a:pPr>
             <a:r>
@@ -4270,6 +4192,13 @@
             <a:prstDash val="solid"/>
           </a:ln>
         </p:spPr>
+        <p:txBody>
+          <a:bodyPr/>
+          <a:lstStyle/>
+          <a:p>
+            <a:endParaRPr lang="en-IN"/>
+          </a:p>
+        </p:txBody>
       </p:sp>
       <p:sp>
         <p:nvSpPr>
@@ -4290,11 +4219,11 @@
         </p:spPr>
         <p:txBody>
           <a:bodyPr wrap="square" lIns="0" tIns="0" rIns="0" bIns="0" rtlCol="0" anchor="ctr">
-            <a:normAutofit/>
-          </a:bodyPr>
-          <a:lstStyle/>
-          <a:p>
-            <a:pPr algn="l" indent="0" marL="0">
+            <a:normAutofit fontScale="92500" lnSpcReduction="10000"/>
+          </a:bodyPr>
+          <a:lstStyle/>
+          <a:p>
+            <a:pPr marL="0" indent="0" algn="l">
               <a:buNone/>
             </a:pPr>
             <a:r>
@@ -4331,11 +4260,11 @@
         </p:spPr>
         <p:txBody>
           <a:bodyPr wrap="square" lIns="0" tIns="0" rIns="0" bIns="0" rtlCol="0" anchor="t">
-            <a:normAutofit/>
-          </a:bodyPr>
-          <a:lstStyle/>
-          <a:p>
-            <a:pPr algn="l" indent="0" marL="0">
+            <a:normAutofit fontScale="92500" lnSpcReduction="20000"/>
+          </a:bodyPr>
+          <a:lstStyle/>
+          <a:p>
+            <a:pPr marL="0" indent="0" algn="l">
               <a:buNone/>
             </a:pPr>
             <a:r>
@@ -4381,6 +4310,13 @@
             <a:prstDash val="solid"/>
           </a:ln>
         </p:spPr>
+        <p:txBody>
+          <a:bodyPr/>
+          <a:lstStyle/>
+          <a:p>
+            <a:endParaRPr lang="en-IN"/>
+          </a:p>
+        </p:txBody>
       </p:sp>
       <p:sp>
         <p:nvSpPr>
@@ -4401,11 +4337,11 @@
         </p:spPr>
         <p:txBody>
           <a:bodyPr wrap="square" lIns="0" tIns="0" rIns="0" bIns="0" rtlCol="0" anchor="ctr">
-            <a:normAutofit/>
-          </a:bodyPr>
-          <a:lstStyle/>
-          <a:p>
-            <a:pPr algn="l" indent="0" marL="0">
+            <a:normAutofit fontScale="92500" lnSpcReduction="10000"/>
+          </a:bodyPr>
+          <a:lstStyle/>
+          <a:p>
+            <a:pPr marL="0" indent="0" algn="l">
               <a:buNone/>
             </a:pPr>
             <a:r>
@@ -4442,11 +4378,11 @@
         </p:spPr>
         <p:txBody>
           <a:bodyPr wrap="square" lIns="0" tIns="0" rIns="0" bIns="0" rtlCol="0" anchor="t">
-            <a:normAutofit/>
-          </a:bodyPr>
-          <a:lstStyle/>
-          <a:p>
-            <a:pPr algn="l" indent="0" marL="0">
+            <a:normAutofit fontScale="92500" lnSpcReduction="20000"/>
+          </a:bodyPr>
+          <a:lstStyle/>
+          <a:p>
+            <a:pPr marL="0" indent="0" algn="l">
               <a:buNone/>
             </a:pPr>
             <a:r>
@@ -4487,7 +4423,7 @@
           </a:bodyPr>
           <a:lstStyle/>
           <a:p>
-            <a:pPr algn="ctr" indent="0" marL="0">
+            <a:pPr marL="0" indent="0" algn="ctr">
               <a:buNone/>
             </a:pPr>
             <a:r>
@@ -4528,7 +4464,7 @@
           </a:bodyPr>
           <a:lstStyle/>
           <a:p>
-            <a:pPr algn="ctr" indent="0" marL="0">
+            <a:pPr marL="0" indent="0" algn="ctr">
               <a:buNone/>
             </a:pPr>
             <a:r>
@@ -4551,7 +4487,7 @@
   <p:clrMapOvr>
     <a:masterClrMapping/>
   </p:clrMapOvr>
-  <p:transition spd="med" advClick="1">
+  <p:transition spd="med">
     <p:fade/>
   </p:transition>
 </p:sld>
@@ -4565,6 +4501,7 @@
         <a:solidFill>
           <a:srgbClr val="F6F9FE"/>
         </a:solidFill>
+        <a:effectLst/>
       </p:bgPr>
     </p:bg>
     <p:spTree>
@@ -4604,7 +4541,7 @@
           </a:bodyPr>
           <a:lstStyle/>
           <a:p>
-            <a:pPr algn="l" indent="0" marL="0">
+            <a:pPr marL="0" indent="0" algn="l">
               <a:buNone/>
             </a:pPr>
             <a:r>
@@ -4641,11 +4578,11 @@
         </p:spPr>
         <p:txBody>
           <a:bodyPr wrap="square" lIns="0" tIns="0" rIns="0" bIns="0" rtlCol="0" anchor="ctr">
-            <a:normAutofit/>
-          </a:bodyPr>
-          <a:lstStyle/>
-          <a:p>
-            <a:pPr algn="l" indent="0" marL="0">
+            <a:normAutofit lnSpcReduction="10000"/>
+          </a:bodyPr>
+          <a:lstStyle/>
+          <a:p>
+            <a:pPr marL="0" indent="0" algn="l">
               <a:buNone/>
             </a:pPr>
             <a:r>
@@ -4686,7 +4623,7 @@
           </a:bodyPr>
           <a:lstStyle/>
           <a:p>
-            <a:pPr algn="l" indent="0" marL="0">
+            <a:pPr marL="0" indent="0" algn="l">
               <a:buNone/>
             </a:pPr>
             <a:r>
@@ -4727,7 +4664,7 @@
           </a:bodyPr>
           <a:lstStyle/>
           <a:p>
-            <a:pPr algn="r" indent="0" marL="0">
+            <a:pPr marL="0" indent="0" algn="r">
               <a:buNone/>
             </a:pPr>
             <a:r>
@@ -4773,6 +4710,13 @@
             <a:prstDash val="solid"/>
           </a:ln>
         </p:spPr>
+        <p:txBody>
+          <a:bodyPr/>
+          <a:lstStyle/>
+          <a:p>
+            <a:endParaRPr lang="en-IN"/>
+          </a:p>
+        </p:txBody>
       </p:sp>
       <p:sp>
         <p:nvSpPr>
@@ -4800,6 +4744,13 @@
             <a:prstDash val="solid"/>
           </a:ln>
         </p:spPr>
+        <p:txBody>
+          <a:bodyPr/>
+          <a:lstStyle/>
+          <a:p>
+            <a:endParaRPr lang="en-IN"/>
+          </a:p>
+        </p:txBody>
       </p:sp>
       <p:sp>
         <p:nvSpPr>
@@ -4820,11 +4771,11 @@
         </p:spPr>
         <p:txBody>
           <a:bodyPr wrap="square" lIns="0" tIns="0" rIns="0" bIns="0" rtlCol="0" anchor="ctr">
-            <a:normAutofit/>
-          </a:bodyPr>
-          <a:lstStyle/>
-          <a:p>
-            <a:pPr algn="ctr" indent="0" marL="0">
+            <a:normAutofit fontScale="92500" lnSpcReduction="20000"/>
+          </a:bodyPr>
+          <a:lstStyle/>
+          <a:p>
+            <a:pPr marL="0" indent="0" algn="ctr">
               <a:buNone/>
             </a:pPr>
             <a:r>
@@ -4861,11 +4812,11 @@
         </p:spPr>
         <p:txBody>
           <a:bodyPr wrap="square" lIns="0" tIns="0" rIns="0" bIns="0" rtlCol="0" anchor="ctr">
-            <a:normAutofit/>
-          </a:bodyPr>
-          <a:lstStyle/>
-          <a:p>
-            <a:pPr algn="l" indent="0" marL="0">
+            <a:normAutofit fontScale="92500" lnSpcReduction="20000"/>
+          </a:bodyPr>
+          <a:lstStyle/>
+          <a:p>
+            <a:pPr marL="0" indent="0" algn="l">
               <a:buNone/>
             </a:pPr>
             <a:r>
@@ -4902,11 +4853,11 @@
         </p:spPr>
         <p:txBody>
           <a:bodyPr wrap="square" lIns="0" tIns="0" rIns="0" bIns="0" rtlCol="0" anchor="t">
-            <a:normAutofit/>
-          </a:bodyPr>
-          <a:lstStyle/>
-          <a:p>
-            <a:pPr algn="l" indent="0" marL="0">
+            <a:normAutofit lnSpcReduction="10000"/>
+          </a:bodyPr>
+          <a:lstStyle/>
+          <a:p>
+            <a:pPr marL="0" indent="0" algn="l">
               <a:buNone/>
             </a:pPr>
             <a:r>
@@ -4947,6 +4898,13 @@
             <a:tailEnd type="triangle"/>
           </a:ln>
         </p:spPr>
+        <p:txBody>
+          <a:bodyPr/>
+          <a:lstStyle/>
+          <a:p>
+            <a:endParaRPr lang="en-IN"/>
+          </a:p>
+        </p:txBody>
       </p:sp>
       <p:sp>
         <p:nvSpPr>
@@ -4976,6 +4934,13 @@
             <a:prstDash val="solid"/>
           </a:ln>
         </p:spPr>
+        <p:txBody>
+          <a:bodyPr/>
+          <a:lstStyle/>
+          <a:p>
+            <a:endParaRPr lang="en-IN"/>
+          </a:p>
+        </p:txBody>
       </p:sp>
       <p:sp>
         <p:nvSpPr>
@@ -5003,6 +4968,13 @@
             <a:prstDash val="solid"/>
           </a:ln>
         </p:spPr>
+        <p:txBody>
+          <a:bodyPr/>
+          <a:lstStyle/>
+          <a:p>
+            <a:endParaRPr lang="en-IN"/>
+          </a:p>
+        </p:txBody>
       </p:sp>
       <p:sp>
         <p:nvSpPr>
@@ -5023,11 +4995,11 @@
         </p:spPr>
         <p:txBody>
           <a:bodyPr wrap="square" lIns="0" tIns="0" rIns="0" bIns="0" rtlCol="0" anchor="ctr">
-            <a:normAutofit/>
-          </a:bodyPr>
-          <a:lstStyle/>
-          <a:p>
-            <a:pPr algn="ctr" indent="0" marL="0">
+            <a:normAutofit fontScale="92500" lnSpcReduction="20000"/>
+          </a:bodyPr>
+          <a:lstStyle/>
+          <a:p>
+            <a:pPr marL="0" indent="0" algn="ctr">
               <a:buNone/>
             </a:pPr>
             <a:r>
@@ -5064,11 +5036,11 @@
         </p:spPr>
         <p:txBody>
           <a:bodyPr wrap="square" lIns="0" tIns="0" rIns="0" bIns="0" rtlCol="0" anchor="ctr">
-            <a:normAutofit/>
-          </a:bodyPr>
-          <a:lstStyle/>
-          <a:p>
-            <a:pPr algn="l" indent="0" marL="0">
+            <a:normAutofit fontScale="92500" lnSpcReduction="20000"/>
+          </a:bodyPr>
+          <a:lstStyle/>
+          <a:p>
+            <a:pPr marL="0" indent="0" algn="l">
               <a:buNone/>
             </a:pPr>
             <a:r>
@@ -5109,7 +5081,7 @@
           </a:bodyPr>
           <a:lstStyle/>
           <a:p>
-            <a:pPr algn="l" indent="0" marL="0">
+            <a:pPr marL="0" indent="0" algn="l">
               <a:buNone/>
             </a:pPr>
             <a:r>
@@ -5150,6 +5122,13 @@
             <a:tailEnd type="triangle"/>
           </a:ln>
         </p:spPr>
+        <p:txBody>
+          <a:bodyPr/>
+          <a:lstStyle/>
+          <a:p>
+            <a:endParaRPr lang="en-IN"/>
+          </a:p>
+        </p:txBody>
       </p:sp>
       <p:sp>
         <p:nvSpPr>
@@ -5179,6 +5158,13 @@
             <a:prstDash val="solid"/>
           </a:ln>
         </p:spPr>
+        <p:txBody>
+          <a:bodyPr/>
+          <a:lstStyle/>
+          <a:p>
+            <a:endParaRPr lang="en-IN"/>
+          </a:p>
+        </p:txBody>
       </p:sp>
       <p:sp>
         <p:nvSpPr>
@@ -5206,6 +5192,13 @@
             <a:prstDash val="solid"/>
           </a:ln>
         </p:spPr>
+        <p:txBody>
+          <a:bodyPr/>
+          <a:lstStyle/>
+          <a:p>
+            <a:endParaRPr lang="en-IN"/>
+          </a:p>
+        </p:txBody>
       </p:sp>
       <p:sp>
         <p:nvSpPr>
@@ -5226,11 +5219,11 @@
         </p:spPr>
         <p:txBody>
           <a:bodyPr wrap="square" lIns="0" tIns="0" rIns="0" bIns="0" rtlCol="0" anchor="ctr">
-            <a:normAutofit/>
-          </a:bodyPr>
-          <a:lstStyle/>
-          <a:p>
-            <a:pPr algn="ctr" indent="0" marL="0">
+            <a:normAutofit fontScale="92500" lnSpcReduction="20000"/>
+          </a:bodyPr>
+          <a:lstStyle/>
+          <a:p>
+            <a:pPr marL="0" indent="0" algn="ctr">
               <a:buNone/>
             </a:pPr>
             <a:r>
@@ -5267,11 +5260,11 @@
         </p:spPr>
         <p:txBody>
           <a:bodyPr wrap="square" lIns="0" tIns="0" rIns="0" bIns="0" rtlCol="0" anchor="ctr">
-            <a:normAutofit/>
-          </a:bodyPr>
-          <a:lstStyle/>
-          <a:p>
-            <a:pPr algn="l" indent="0" marL="0">
+            <a:normAutofit fontScale="92500" lnSpcReduction="20000"/>
+          </a:bodyPr>
+          <a:lstStyle/>
+          <a:p>
+            <a:pPr marL="0" indent="0" algn="l">
               <a:buNone/>
             </a:pPr>
             <a:r>
@@ -5308,11 +5301,11 @@
         </p:spPr>
         <p:txBody>
           <a:bodyPr wrap="square" lIns="0" tIns="0" rIns="0" bIns="0" rtlCol="0" anchor="t">
-            <a:normAutofit/>
-          </a:bodyPr>
-          <a:lstStyle/>
-          <a:p>
-            <a:pPr algn="l" indent="0" marL="0">
+            <a:normAutofit lnSpcReduction="10000"/>
+          </a:bodyPr>
+          <a:lstStyle/>
+          <a:p>
+            <a:pPr marL="0" indent="0" algn="l">
               <a:buNone/>
             </a:pPr>
             <a:r>
@@ -5353,6 +5346,13 @@
             <a:tailEnd type="triangle"/>
           </a:ln>
         </p:spPr>
+        <p:txBody>
+          <a:bodyPr/>
+          <a:lstStyle/>
+          <a:p>
+            <a:endParaRPr lang="en-IN"/>
+          </a:p>
+        </p:txBody>
       </p:sp>
       <p:sp>
         <p:nvSpPr>
@@ -5382,6 +5382,13 @@
             <a:prstDash val="solid"/>
           </a:ln>
         </p:spPr>
+        <p:txBody>
+          <a:bodyPr/>
+          <a:lstStyle/>
+          <a:p>
+            <a:endParaRPr lang="en-IN"/>
+          </a:p>
+        </p:txBody>
       </p:sp>
       <p:sp>
         <p:nvSpPr>
@@ -5409,6 +5416,13 @@
             <a:prstDash val="solid"/>
           </a:ln>
         </p:spPr>
+        <p:txBody>
+          <a:bodyPr/>
+          <a:lstStyle/>
+          <a:p>
+            <a:endParaRPr lang="en-IN"/>
+          </a:p>
+        </p:txBody>
       </p:sp>
       <p:sp>
         <p:nvSpPr>
@@ -5429,11 +5443,11 @@
         </p:spPr>
         <p:txBody>
           <a:bodyPr wrap="square" lIns="0" tIns="0" rIns="0" bIns="0" rtlCol="0" anchor="ctr">
-            <a:normAutofit/>
-          </a:bodyPr>
-          <a:lstStyle/>
-          <a:p>
-            <a:pPr algn="ctr" indent="0" marL="0">
+            <a:normAutofit fontScale="92500" lnSpcReduction="20000"/>
+          </a:bodyPr>
+          <a:lstStyle/>
+          <a:p>
+            <a:pPr marL="0" indent="0" algn="ctr">
               <a:buNone/>
             </a:pPr>
             <a:r>
@@ -5470,11 +5484,11 @@
         </p:spPr>
         <p:txBody>
           <a:bodyPr wrap="square" lIns="0" tIns="0" rIns="0" bIns="0" rtlCol="0" anchor="ctr">
-            <a:normAutofit/>
-          </a:bodyPr>
-          <a:lstStyle/>
-          <a:p>
-            <a:pPr algn="l" indent="0" marL="0">
+            <a:normAutofit fontScale="92500" lnSpcReduction="20000"/>
+          </a:bodyPr>
+          <a:lstStyle/>
+          <a:p>
+            <a:pPr marL="0" indent="0" algn="l">
               <a:buNone/>
             </a:pPr>
             <a:r>
@@ -5511,11 +5525,11 @@
         </p:spPr>
         <p:txBody>
           <a:bodyPr wrap="square" lIns="0" tIns="0" rIns="0" bIns="0" rtlCol="0" anchor="t">
-            <a:normAutofit/>
-          </a:bodyPr>
-          <a:lstStyle/>
-          <a:p>
-            <a:pPr algn="l" indent="0" marL="0">
+            <a:normAutofit lnSpcReduction="10000"/>
+          </a:bodyPr>
+          <a:lstStyle/>
+          <a:p>
+            <a:pPr marL="0" indent="0" algn="l">
               <a:buNone/>
             </a:pPr>
             <a:r>
@@ -5556,6 +5570,13 @@
             <a:tailEnd type="triangle"/>
           </a:ln>
         </p:spPr>
+        <p:txBody>
+          <a:bodyPr/>
+          <a:lstStyle/>
+          <a:p>
+            <a:endParaRPr lang="en-IN"/>
+          </a:p>
+        </p:txBody>
       </p:sp>
       <p:sp>
         <p:nvSpPr>
@@ -5585,6 +5606,13 @@
             <a:prstDash val="solid"/>
           </a:ln>
         </p:spPr>
+        <p:txBody>
+          <a:bodyPr/>
+          <a:lstStyle/>
+          <a:p>
+            <a:endParaRPr lang="en-IN"/>
+          </a:p>
+        </p:txBody>
       </p:sp>
       <p:sp>
         <p:nvSpPr>
@@ -5612,6 +5640,13 @@
             <a:prstDash val="solid"/>
           </a:ln>
         </p:spPr>
+        <p:txBody>
+          <a:bodyPr/>
+          <a:lstStyle/>
+          <a:p>
+            <a:endParaRPr lang="en-IN"/>
+          </a:p>
+        </p:txBody>
       </p:sp>
       <p:sp>
         <p:nvSpPr>
@@ -5632,11 +5667,11 @@
         </p:spPr>
         <p:txBody>
           <a:bodyPr wrap="square" lIns="0" tIns="0" rIns="0" bIns="0" rtlCol="0" anchor="ctr">
-            <a:normAutofit/>
-          </a:bodyPr>
-          <a:lstStyle/>
-          <a:p>
-            <a:pPr algn="ctr" indent="0" marL="0">
+            <a:normAutofit fontScale="92500" lnSpcReduction="20000"/>
+          </a:bodyPr>
+          <a:lstStyle/>
+          <a:p>
+            <a:pPr marL="0" indent="0" algn="ctr">
               <a:buNone/>
             </a:pPr>
             <a:r>
@@ -5673,11 +5708,11 @@
         </p:spPr>
         <p:txBody>
           <a:bodyPr wrap="square" lIns="0" tIns="0" rIns="0" bIns="0" rtlCol="0" anchor="ctr">
-            <a:normAutofit/>
-          </a:bodyPr>
-          <a:lstStyle/>
-          <a:p>
-            <a:pPr algn="l" indent="0" marL="0">
+            <a:normAutofit fontScale="92500" lnSpcReduction="20000"/>
+          </a:bodyPr>
+          <a:lstStyle/>
+          <a:p>
+            <a:pPr marL="0" indent="0" algn="l">
               <a:buNone/>
             </a:pPr>
             <a:r>
@@ -5714,11 +5749,11 @@
         </p:spPr>
         <p:txBody>
           <a:bodyPr wrap="square" lIns="0" tIns="0" rIns="0" bIns="0" rtlCol="0" anchor="t">
-            <a:normAutofit/>
-          </a:bodyPr>
-          <a:lstStyle/>
-          <a:p>
-            <a:pPr algn="l" indent="0" marL="0">
+            <a:normAutofit lnSpcReduction="10000"/>
+          </a:bodyPr>
+          <a:lstStyle/>
+          <a:p>
+            <a:pPr marL="0" indent="0" algn="l">
               <a:buNone/>
             </a:pPr>
             <a:r>
@@ -5755,11 +5790,11 @@
         </p:spPr>
         <p:txBody>
           <a:bodyPr wrap="square" lIns="0" tIns="0" rIns="0" bIns="0" rtlCol="0" anchor="ctr">
-            <a:normAutofit/>
-          </a:bodyPr>
-          <a:lstStyle/>
-          <a:p>
-            <a:pPr algn="ctr" indent="0" marL="0">
+            <a:normAutofit fontScale="85000" lnSpcReduction="10000"/>
+          </a:bodyPr>
+          <a:lstStyle/>
+          <a:p>
+            <a:pPr marL="0" indent="0" algn="ctr">
               <a:buNone/>
             </a:pPr>
             <a:r>
@@ -5782,7 +5817,7 @@
   <p:clrMapOvr>
     <a:masterClrMapping/>
   </p:clrMapOvr>
-  <p:transition spd="med" advClick="1">
+  <p:transition spd="med">
     <p:fade/>
   </p:transition>
 </p:sld>
@@ -5796,6 +5831,7 @@
         <a:solidFill>
           <a:srgbClr val="0B1F3A"/>
         </a:solidFill>
+        <a:effectLst/>
       </p:bgPr>
     </p:bg>
     <p:spTree>
@@ -5835,7 +5871,7 @@
           </a:bodyPr>
           <a:lstStyle/>
           <a:p>
-            <a:pPr algn="l" indent="0" marL="0">
+            <a:pPr marL="0" indent="0" algn="l">
               <a:buNone/>
             </a:pPr>
             <a:r>
@@ -5872,11 +5908,11 @@
         </p:spPr>
         <p:txBody>
           <a:bodyPr wrap="square" lIns="0" tIns="0" rIns="0" bIns="0" rtlCol="0" anchor="ctr">
-            <a:normAutofit/>
-          </a:bodyPr>
-          <a:lstStyle/>
-          <a:p>
-            <a:pPr algn="l" indent="0" marL="0">
+            <a:normAutofit fontScale="77500" lnSpcReduction="20000"/>
+          </a:bodyPr>
+          <a:lstStyle/>
+          <a:p>
+            <a:pPr marL="0" indent="0" algn="l">
               <a:buNone/>
             </a:pPr>
             <a:r>
@@ -5917,7 +5953,7 @@
           </a:bodyPr>
           <a:lstStyle/>
           <a:p>
-            <a:pPr algn="l" indent="0" marL="0">
+            <a:pPr marL="0" indent="0" algn="l">
               <a:buNone/>
             </a:pPr>
             <a:r>
@@ -5958,7 +5994,7 @@
           </a:bodyPr>
           <a:lstStyle/>
           <a:p>
-            <a:pPr algn="r" indent="0" marL="0">
+            <a:pPr marL="0" indent="0" algn="r">
               <a:buNone/>
             </a:pPr>
             <a:r>
@@ -6004,17 +6040,24 @@
             <a:prstDash val="solid"/>
           </a:ln>
         </p:spPr>
+        <p:txBody>
+          <a:bodyPr/>
+          <a:lstStyle/>
+          <a:p>
+            <a:endParaRPr lang="en-IN"/>
+          </a:p>
+        </p:txBody>
       </p:sp>
       <p:pic>
         <p:nvPicPr>
-          <p:cNvPr id="7" name="Image 0" descr="C:\D\IIT Mumbai\Capstone Blueprint\assets\walkthrough_screens\2026_workspace_confidence.png">    </p:cNvPr>
+          <p:cNvPr id="7" name="Image 0" descr="C:\D\IIT Mumbai\Capstone Blueprint\assets\walkthrough_screens\2026_workspace_confidence.png"/>
           <p:cNvPicPr>
             <a:picLocks noChangeAspect="1"/>
           </p:cNvPicPr>
           <p:nvPr/>
         </p:nvPicPr>
         <p:blipFill>
-          <a:blip r:embed="rId1"/>
+          <a:blip r:embed="rId3"/>
           <a:stretch>
             <a:fillRect/>
           </a:stretch>
@@ -6057,6 +6100,13 @@
             <a:prstDash val="solid"/>
           </a:ln>
         </p:spPr>
+        <p:txBody>
+          <a:bodyPr/>
+          <a:lstStyle/>
+          <a:p>
+            <a:endParaRPr lang="en-IN"/>
+          </a:p>
+        </p:txBody>
       </p:sp>
       <p:sp>
         <p:nvSpPr>
@@ -6077,11 +6127,11 @@
         </p:spPr>
         <p:txBody>
           <a:bodyPr wrap="square" lIns="0" tIns="0" rIns="0" bIns="0" rtlCol="0" anchor="ctr">
-            <a:normAutofit/>
-          </a:bodyPr>
-          <a:lstStyle/>
-          <a:p>
-            <a:pPr algn="l" indent="0" marL="0">
+            <a:normAutofit fontScale="92500" lnSpcReduction="10000"/>
+          </a:bodyPr>
+          <a:lstStyle/>
+          <a:p>
+            <a:pPr marL="0" indent="0" algn="l">
               <a:buNone/>
             </a:pPr>
             <a:r>
@@ -6118,11 +6168,11 @@
         </p:spPr>
         <p:txBody>
           <a:bodyPr wrap="square" lIns="0" tIns="0" rIns="0" bIns="0" rtlCol="0" anchor="t">
-            <a:normAutofit/>
-          </a:bodyPr>
-          <a:lstStyle/>
-          <a:p>
-            <a:pPr algn="l" indent="0" marL="0">
+            <a:normAutofit fontScale="92500" lnSpcReduction="10000"/>
+          </a:bodyPr>
+          <a:lstStyle/>
+          <a:p>
+            <a:pPr marL="0" indent="0" algn="l">
               <a:buNone/>
             </a:pPr>
             <a:r>
@@ -6168,6 +6218,13 @@
             <a:prstDash val="solid"/>
           </a:ln>
         </p:spPr>
+        <p:txBody>
+          <a:bodyPr/>
+          <a:lstStyle/>
+          <a:p>
+            <a:endParaRPr lang="en-IN"/>
+          </a:p>
+        </p:txBody>
       </p:sp>
       <p:sp>
         <p:nvSpPr>
@@ -6188,11 +6245,11 @@
         </p:spPr>
         <p:txBody>
           <a:bodyPr wrap="square" lIns="0" tIns="0" rIns="0" bIns="0" rtlCol="0" anchor="ctr">
-            <a:normAutofit/>
-          </a:bodyPr>
-          <a:lstStyle/>
-          <a:p>
-            <a:pPr algn="l" indent="0" marL="0">
+            <a:normAutofit fontScale="92500" lnSpcReduction="10000"/>
+          </a:bodyPr>
+          <a:lstStyle/>
+          <a:p>
+            <a:pPr marL="0" indent="0" algn="l">
               <a:buNone/>
             </a:pPr>
             <a:r>
@@ -6229,11 +6286,11 @@
         </p:spPr>
         <p:txBody>
           <a:bodyPr wrap="square" lIns="0" tIns="0" rIns="0" bIns="0" rtlCol="0" anchor="t">
-            <a:normAutofit/>
-          </a:bodyPr>
-          <a:lstStyle/>
-          <a:p>
-            <a:pPr algn="l" indent="0" marL="0">
+            <a:normAutofit fontScale="92500"/>
+          </a:bodyPr>
+          <a:lstStyle/>
+          <a:p>
+            <a:pPr marL="0" indent="0" algn="l">
               <a:buNone/>
             </a:pPr>
             <a:r>
@@ -6279,6 +6336,13 @@
             <a:prstDash val="solid"/>
           </a:ln>
         </p:spPr>
+        <p:txBody>
+          <a:bodyPr/>
+          <a:lstStyle/>
+          <a:p>
+            <a:endParaRPr lang="en-IN"/>
+          </a:p>
+        </p:txBody>
       </p:sp>
       <p:sp>
         <p:nvSpPr>
@@ -6299,11 +6363,11 @@
         </p:spPr>
         <p:txBody>
           <a:bodyPr wrap="square" lIns="0" tIns="0" rIns="0" bIns="0" rtlCol="0" anchor="ctr">
-            <a:normAutofit/>
-          </a:bodyPr>
-          <a:lstStyle/>
-          <a:p>
-            <a:pPr algn="l" indent="0" marL="0">
+            <a:normAutofit fontScale="92500" lnSpcReduction="10000"/>
+          </a:bodyPr>
+          <a:lstStyle/>
+          <a:p>
+            <a:pPr marL="0" indent="0" algn="l">
               <a:buNone/>
             </a:pPr>
             <a:r>
@@ -6340,11 +6404,11 @@
         </p:spPr>
         <p:txBody>
           <a:bodyPr wrap="square" lIns="0" tIns="0" rIns="0" bIns="0" rtlCol="0" anchor="t">
-            <a:normAutofit/>
-          </a:bodyPr>
-          <a:lstStyle/>
-          <a:p>
-            <a:pPr algn="l" indent="0" marL="0">
+            <a:normAutofit fontScale="92500" lnSpcReduction="10000"/>
+          </a:bodyPr>
+          <a:lstStyle/>
+          <a:p>
+            <a:pPr marL="0" indent="0" algn="l">
               <a:buNone/>
             </a:pPr>
             <a:r>
@@ -6367,7 +6431,7 @@
   <p:clrMapOvr>
     <a:masterClrMapping/>
   </p:clrMapOvr>
-  <p:transition spd="med" advClick="1">
+  <p:transition spd="med">
     <p:fade/>
   </p:transition>
 </p:sld>
@@ -6381,6 +6445,7 @@
         <a:solidFill>
           <a:srgbClr val="F6F9FE"/>
         </a:solidFill>
+        <a:effectLst/>
       </p:bgPr>
     </p:bg>
     <p:spTree>
@@ -6420,7 +6485,7 @@
           </a:bodyPr>
           <a:lstStyle/>
           <a:p>
-            <a:pPr algn="l" indent="0" marL="0">
+            <a:pPr marL="0" indent="0" algn="l">
               <a:buNone/>
             </a:pPr>
             <a:r>
@@ -6457,11 +6522,11 @@
         </p:spPr>
         <p:txBody>
           <a:bodyPr wrap="square" lIns="0" tIns="0" rIns="0" bIns="0" rtlCol="0" anchor="ctr">
-            <a:normAutofit/>
-          </a:bodyPr>
-          <a:lstStyle/>
-          <a:p>
-            <a:pPr algn="l" indent="0" marL="0">
+            <a:normAutofit lnSpcReduction="10000"/>
+          </a:bodyPr>
+          <a:lstStyle/>
+          <a:p>
+            <a:pPr marL="0" indent="0" algn="l">
               <a:buNone/>
             </a:pPr>
             <a:r>
@@ -6502,7 +6567,7 @@
           </a:bodyPr>
           <a:lstStyle/>
           <a:p>
-            <a:pPr algn="l" indent="0" marL="0">
+            <a:pPr marL="0" indent="0" algn="l">
               <a:buNone/>
             </a:pPr>
             <a:r>
@@ -6543,7 +6608,7 @@
           </a:bodyPr>
           <a:lstStyle/>
           <a:p>
-            <a:pPr algn="r" indent="0" marL="0">
+            <a:pPr marL="0" indent="0" algn="r">
               <a:buNone/>
             </a:pPr>
             <a:r>
@@ -6589,17 +6654,24 @@
             <a:prstDash val="solid"/>
           </a:ln>
         </p:spPr>
+        <p:txBody>
+          <a:bodyPr/>
+          <a:lstStyle/>
+          <a:p>
+            <a:endParaRPr lang="en-IN"/>
+          </a:p>
+        </p:txBody>
       </p:sp>
       <p:pic>
         <p:nvPicPr>
-          <p:cNvPr id="7" name="Image 0" descr="C:\D\IIT Mumbai\Capstone Blueprint\assets\walkthrough_screens\2026_evidence_source_chunks_detail.png">    </p:cNvPr>
+          <p:cNvPr id="7" name="Image 0" descr="C:\D\IIT Mumbai\Capstone Blueprint\assets\walkthrough_screens\2026_evidence_source_chunks_detail.png"/>
           <p:cNvPicPr>
             <a:picLocks noChangeAspect="1"/>
           </p:cNvPicPr>
           <p:nvPr/>
         </p:nvPicPr>
         <p:blipFill>
-          <a:blip r:embed="rId1"/>
+          <a:blip r:embed="rId3"/>
           <a:stretch>
             <a:fillRect/>
           </a:stretch>
@@ -6640,6 +6712,13 @@
             <a:prstDash val="solid"/>
           </a:ln>
         </p:spPr>
+        <p:txBody>
+          <a:bodyPr/>
+          <a:lstStyle/>
+          <a:p>
+            <a:endParaRPr lang="en-IN"/>
+          </a:p>
+        </p:txBody>
       </p:sp>
       <p:sp>
         <p:nvSpPr>
@@ -6660,11 +6739,11 @@
         </p:spPr>
         <p:txBody>
           <a:bodyPr wrap="square" lIns="0" tIns="0" rIns="0" bIns="0" rtlCol="0" anchor="ctr">
-            <a:normAutofit/>
-          </a:bodyPr>
-          <a:lstStyle/>
-          <a:p>
-            <a:pPr algn="ctr" indent="0" marL="0">
+            <a:normAutofit fontScale="92500" lnSpcReduction="20000"/>
+          </a:bodyPr>
+          <a:lstStyle/>
+          <a:p>
+            <a:pPr marL="0" indent="0" algn="ctr">
               <a:buNone/>
             </a:pPr>
             <a:r>
@@ -6701,11 +6780,11 @@
         </p:spPr>
         <p:txBody>
           <a:bodyPr wrap="square" lIns="0" tIns="0" rIns="0" bIns="0" rtlCol="0" anchor="ctr">
-            <a:normAutofit/>
-          </a:bodyPr>
-          <a:lstStyle/>
-          <a:p>
-            <a:pPr algn="l" indent="0" marL="0">
+            <a:normAutofit fontScale="92500" lnSpcReduction="10000"/>
+          </a:bodyPr>
+          <a:lstStyle/>
+          <a:p>
+            <a:pPr marL="0" indent="0" algn="l">
               <a:buNone/>
             </a:pPr>
             <a:r>
@@ -6746,7 +6825,7 @@
           </a:bodyPr>
           <a:lstStyle/>
           <a:p>
-            <a:pPr algn="l" indent="0" marL="0">
+            <a:pPr marL="0" indent="0" algn="l">
               <a:buNone/>
             </a:pPr>
             <a:r>
@@ -6790,6 +6869,13 @@
             <a:prstDash val="solid"/>
           </a:ln>
         </p:spPr>
+        <p:txBody>
+          <a:bodyPr/>
+          <a:lstStyle/>
+          <a:p>
+            <a:endParaRPr lang="en-IN"/>
+          </a:p>
+        </p:txBody>
       </p:sp>
       <p:sp>
         <p:nvSpPr>
@@ -6810,11 +6896,11 @@
         </p:spPr>
         <p:txBody>
           <a:bodyPr wrap="square" lIns="0" tIns="0" rIns="0" bIns="0" rtlCol="0" anchor="ctr">
-            <a:normAutofit/>
-          </a:bodyPr>
-          <a:lstStyle/>
-          <a:p>
-            <a:pPr algn="ctr" indent="0" marL="0">
+            <a:normAutofit fontScale="92500" lnSpcReduction="20000"/>
+          </a:bodyPr>
+          <a:lstStyle/>
+          <a:p>
+            <a:pPr marL="0" indent="0" algn="ctr">
               <a:buNone/>
             </a:pPr>
             <a:r>
@@ -6851,11 +6937,11 @@
         </p:spPr>
         <p:txBody>
           <a:bodyPr wrap="square" lIns="0" tIns="0" rIns="0" bIns="0" rtlCol="0" anchor="ctr">
-            <a:normAutofit/>
-          </a:bodyPr>
-          <a:lstStyle/>
-          <a:p>
-            <a:pPr algn="l" indent="0" marL="0">
+            <a:normAutofit fontScale="92500" lnSpcReduction="10000"/>
+          </a:bodyPr>
+          <a:lstStyle/>
+          <a:p>
+            <a:pPr marL="0" indent="0" algn="l">
               <a:buNone/>
             </a:pPr>
             <a:r>
@@ -6896,7 +6982,7 @@
           </a:bodyPr>
           <a:lstStyle/>
           <a:p>
-            <a:pPr algn="l" indent="0" marL="0">
+            <a:pPr marL="0" indent="0" algn="l">
               <a:buNone/>
             </a:pPr>
             <a:r>
@@ -6940,6 +7026,13 @@
             <a:prstDash val="solid"/>
           </a:ln>
         </p:spPr>
+        <p:txBody>
+          <a:bodyPr/>
+          <a:lstStyle/>
+          <a:p>
+            <a:endParaRPr lang="en-IN"/>
+          </a:p>
+        </p:txBody>
       </p:sp>
       <p:sp>
         <p:nvSpPr>
@@ -6960,11 +7053,11 @@
         </p:spPr>
         <p:txBody>
           <a:bodyPr wrap="square" lIns="0" tIns="0" rIns="0" bIns="0" rtlCol="0" anchor="ctr">
-            <a:normAutofit/>
-          </a:bodyPr>
-          <a:lstStyle/>
-          <a:p>
-            <a:pPr algn="ctr" indent="0" marL="0">
+            <a:normAutofit fontScale="92500" lnSpcReduction="20000"/>
+          </a:bodyPr>
+          <a:lstStyle/>
+          <a:p>
+            <a:pPr marL="0" indent="0" algn="ctr">
               <a:buNone/>
             </a:pPr>
             <a:r>
@@ -7001,11 +7094,11 @@
         </p:spPr>
         <p:txBody>
           <a:bodyPr wrap="square" lIns="0" tIns="0" rIns="0" bIns="0" rtlCol="0" anchor="ctr">
-            <a:normAutofit/>
-          </a:bodyPr>
-          <a:lstStyle/>
-          <a:p>
-            <a:pPr algn="l" indent="0" marL="0">
+            <a:normAutofit fontScale="92500" lnSpcReduction="10000"/>
+          </a:bodyPr>
+          <a:lstStyle/>
+          <a:p>
+            <a:pPr marL="0" indent="0" algn="l">
               <a:buNone/>
             </a:pPr>
             <a:r>
@@ -7046,7 +7139,7 @@
           </a:bodyPr>
           <a:lstStyle/>
           <a:p>
-            <a:pPr algn="l" indent="0" marL="0">
+            <a:pPr marL="0" indent="0" algn="l">
               <a:buNone/>
             </a:pPr>
             <a:r>
@@ -7090,6 +7183,13 @@
             <a:prstDash val="solid"/>
           </a:ln>
         </p:spPr>
+        <p:txBody>
+          <a:bodyPr/>
+          <a:lstStyle/>
+          <a:p>
+            <a:endParaRPr lang="en-IN"/>
+          </a:p>
+        </p:txBody>
       </p:sp>
       <p:sp>
         <p:nvSpPr>
@@ -7110,11 +7210,11 @@
         </p:spPr>
         <p:txBody>
           <a:bodyPr wrap="square" lIns="0" tIns="0" rIns="0" bIns="0" rtlCol="0" anchor="ctr">
-            <a:normAutofit/>
-          </a:bodyPr>
-          <a:lstStyle/>
-          <a:p>
-            <a:pPr algn="ctr" indent="0" marL="0">
+            <a:normAutofit fontScale="92500" lnSpcReduction="20000"/>
+          </a:bodyPr>
+          <a:lstStyle/>
+          <a:p>
+            <a:pPr marL="0" indent="0" algn="ctr">
               <a:buNone/>
             </a:pPr>
             <a:r>
@@ -7151,11 +7251,11 @@
         </p:spPr>
         <p:txBody>
           <a:bodyPr wrap="square" lIns="0" tIns="0" rIns="0" bIns="0" rtlCol="0" anchor="ctr">
-            <a:normAutofit/>
-          </a:bodyPr>
-          <a:lstStyle/>
-          <a:p>
-            <a:pPr algn="l" indent="0" marL="0">
+            <a:normAutofit fontScale="92500" lnSpcReduction="10000"/>
+          </a:bodyPr>
+          <a:lstStyle/>
+          <a:p>
+            <a:pPr marL="0" indent="0" algn="l">
               <a:buNone/>
             </a:pPr>
             <a:r>
@@ -7192,11 +7292,11 @@
         </p:spPr>
         <p:txBody>
           <a:bodyPr wrap="square" lIns="0" tIns="0" rIns="0" bIns="0" rtlCol="0" anchor="t">
-            <a:normAutofit/>
-          </a:bodyPr>
-          <a:lstStyle/>
-          <a:p>
-            <a:pPr algn="l" indent="0" marL="0">
+            <a:normAutofit fontScale="92500"/>
+          </a:bodyPr>
+          <a:lstStyle/>
+          <a:p>
+            <a:pPr marL="0" indent="0" algn="l">
               <a:buNone/>
             </a:pPr>
             <a:r>
@@ -7242,6 +7342,13 @@
             <a:prstDash val="solid"/>
           </a:ln>
         </p:spPr>
+        <p:txBody>
+          <a:bodyPr/>
+          <a:lstStyle/>
+          <a:p>
+            <a:endParaRPr lang="en-IN"/>
+          </a:p>
+        </p:txBody>
       </p:sp>
       <p:sp>
         <p:nvSpPr>
@@ -7262,11 +7369,11 @@
         </p:spPr>
         <p:txBody>
           <a:bodyPr wrap="square" lIns="0" tIns="0" rIns="0" bIns="0" rtlCol="0" anchor="ctr">
-            <a:normAutofit/>
-          </a:bodyPr>
-          <a:lstStyle/>
-          <a:p>
-            <a:pPr algn="ctr" indent="0" marL="0">
+            <a:normAutofit fontScale="77500" lnSpcReduction="20000"/>
+          </a:bodyPr>
+          <a:lstStyle/>
+          <a:p>
+            <a:pPr marL="0" indent="0" algn="ctr">
               <a:buNone/>
             </a:pPr>
             <a:r>
@@ -7289,7 +7396,7 @@
   <p:clrMapOvr>
     <a:masterClrMapping/>
   </p:clrMapOvr>
-  <p:transition spd="med" advClick="1">
+  <p:transition spd="med">
     <p:fade/>
   </p:transition>
 </p:sld>
@@ -7303,6 +7410,7 @@
         <a:solidFill>
           <a:srgbClr val="F6F9FE"/>
         </a:solidFill>
+        <a:effectLst/>
       </p:bgPr>
     </p:bg>
     <p:spTree>
@@ -7321,17 +7429,17 @@
       </p:grpSpPr>
       <p:pic>
         <p:nvPicPr>
-          <p:cNvPr id="2" name="Image 0" descr="C:\D\IIT Mumbai\Capstone Blueprint\assets\walkthrough_screens\2026_data_flow_diagram_v2.svg">    </p:cNvPr>
+          <p:cNvPr id="2" name="Image 0" descr="C:\D\IIT Mumbai\Capstone Blueprint\assets\walkthrough_screens\2026_data_flow_diagram_v2.svg"/>
           <p:cNvPicPr>
             <a:picLocks noChangeAspect="1"/>
           </p:cNvPicPr>
           <p:nvPr/>
         </p:nvPicPr>
         <p:blipFill>
-          <a:blip r:embed="rId1">
+          <a:blip>
             <a:extLst>
               <a:ext uri="{96DAC541-7B7A-43D3-8B79-37D633B846F1}">
-                <asvg:svgBlip xmlns:asvg="http://schemas.microsoft.com/office/drawing/2016/SVG/main" r:embed="rId2"/>
+                <asvg:svgBlip xmlns:asvg="http://schemas.microsoft.com/office/drawing/2016/SVG/main" r:embed="rId3"/>
               </a:ext>
             </a:extLst>
           </a:blip>
@@ -7372,7 +7480,7 @@
           </a:bodyPr>
           <a:lstStyle/>
           <a:p>
-            <a:pPr algn="l" indent="0" marL="0">
+            <a:pPr marL="0" indent="0" algn="l">
               <a:buNone/>
             </a:pPr>
             <a:r>
@@ -7413,7 +7521,7 @@
           </a:bodyPr>
           <a:lstStyle/>
           <a:p>
-            <a:pPr algn="r" indent="0" marL="0">
+            <a:pPr marL="0" indent="0" algn="r">
               <a:buNone/>
             </a:pPr>
             <a:r>
@@ -7436,7 +7544,7 @@
   <p:clrMapOvr>
     <a:masterClrMapping/>
   </p:clrMapOvr>
-  <p:transition spd="med" advClick="1">
+  <p:transition spd="med">
     <p:fade/>
   </p:transition>
 </p:sld>
@@ -7450,6 +7558,7 @@
         <a:solidFill>
           <a:srgbClr val="0B1F3A"/>
         </a:solidFill>
+        <a:effectLst/>
       </p:bgPr>
     </p:bg>
     <p:spTree>
@@ -7489,7 +7598,7 @@
           </a:bodyPr>
           <a:lstStyle/>
           <a:p>
-            <a:pPr algn="l" indent="0" marL="0">
+            <a:pPr marL="0" indent="0" algn="l">
               <a:buNone/>
             </a:pPr>
             <a:r>
@@ -7526,11 +7635,11 @@
         </p:spPr>
         <p:txBody>
           <a:bodyPr wrap="square" lIns="0" tIns="0" rIns="0" bIns="0" rtlCol="0" anchor="ctr">
-            <a:normAutofit/>
-          </a:bodyPr>
-          <a:lstStyle/>
-          <a:p>
-            <a:pPr algn="l" indent="0" marL="0">
+            <a:normAutofit fontScale="85000" lnSpcReduction="10000"/>
+          </a:bodyPr>
+          <a:lstStyle/>
+          <a:p>
+            <a:pPr marL="0" indent="0" algn="l">
               <a:buNone/>
             </a:pPr>
             <a:r>
@@ -7571,7 +7680,7 @@
           </a:bodyPr>
           <a:lstStyle/>
           <a:p>
-            <a:pPr algn="l" indent="0" marL="0">
+            <a:pPr marL="0" indent="0" algn="l">
               <a:buNone/>
             </a:pPr>
             <a:r>
@@ -7612,7 +7721,7 @@
           </a:bodyPr>
           <a:lstStyle/>
           <a:p>
-            <a:pPr algn="r" indent="0" marL="0">
+            <a:pPr marL="0" indent="0" algn="r">
               <a:buNone/>
             </a:pPr>
             <a:r>
@@ -7658,6 +7767,13 @@
             <a:prstDash val="solid"/>
           </a:ln>
         </p:spPr>
+        <p:txBody>
+          <a:bodyPr/>
+          <a:lstStyle/>
+          <a:p>
+            <a:endParaRPr lang="en-IN"/>
+          </a:p>
+        </p:txBody>
       </p:sp>
       <p:sp>
         <p:nvSpPr>
@@ -7678,11 +7794,11 @@
         </p:spPr>
         <p:txBody>
           <a:bodyPr wrap="square" lIns="0" tIns="0" rIns="0" bIns="0" rtlCol="0" anchor="ctr">
-            <a:normAutofit/>
-          </a:bodyPr>
-          <a:lstStyle/>
-          <a:p>
-            <a:pPr algn="l" indent="0" marL="0">
+            <a:normAutofit fontScale="92500" lnSpcReduction="20000"/>
+          </a:bodyPr>
+          <a:lstStyle/>
+          <a:p>
+            <a:pPr marL="0" indent="0" algn="l">
               <a:buNone/>
             </a:pPr>
             <a:r>
@@ -7719,11 +7835,11 @@
         </p:spPr>
         <p:txBody>
           <a:bodyPr wrap="square" lIns="0" tIns="0" rIns="0" bIns="0" rtlCol="0" anchor="ctr">
-            <a:normAutofit/>
-          </a:bodyPr>
-          <a:lstStyle/>
-          <a:p>
-            <a:pPr algn="l" indent="0" marL="0">
+            <a:normAutofit fontScale="77500" lnSpcReduction="20000"/>
+          </a:bodyPr>
+          <a:lstStyle/>
+          <a:p>
+            <a:pPr marL="0" indent="0" algn="l">
               <a:buNone/>
             </a:pPr>
             <a:r>
@@ -7764,7 +7880,7 @@
           </a:bodyPr>
           <a:lstStyle/>
           <a:p>
-            <a:pPr algn="l" indent="0" marL="0">
+            <a:pPr marL="0" indent="0" algn="l">
               <a:buNone/>
             </a:pPr>
             <a:r>
@@ -7810,6 +7926,13 @@
             <a:prstDash val="solid"/>
           </a:ln>
         </p:spPr>
+        <p:txBody>
+          <a:bodyPr/>
+          <a:lstStyle/>
+          <a:p>
+            <a:endParaRPr lang="en-IN"/>
+          </a:p>
+        </p:txBody>
       </p:sp>
       <p:sp>
         <p:nvSpPr>
@@ -7830,11 +7953,11 @@
         </p:spPr>
         <p:txBody>
           <a:bodyPr wrap="square" lIns="0" tIns="0" rIns="0" bIns="0" rtlCol="0" anchor="ctr">
-            <a:normAutofit/>
-          </a:bodyPr>
-          <a:lstStyle/>
-          <a:p>
-            <a:pPr algn="l" indent="0" marL="0">
+            <a:normAutofit fontScale="92500" lnSpcReduction="20000"/>
+          </a:bodyPr>
+          <a:lstStyle/>
+          <a:p>
+            <a:pPr marL="0" indent="0" algn="l">
               <a:buNone/>
             </a:pPr>
             <a:r>
@@ -7871,11 +7994,11 @@
         </p:spPr>
         <p:txBody>
           <a:bodyPr wrap="square" lIns="0" tIns="0" rIns="0" bIns="0" rtlCol="0" anchor="ctr">
-            <a:normAutofit/>
-          </a:bodyPr>
-          <a:lstStyle/>
-          <a:p>
-            <a:pPr algn="l" indent="0" marL="0">
+            <a:normAutofit fontScale="92500" lnSpcReduction="20000"/>
+          </a:bodyPr>
+          <a:lstStyle/>
+          <a:p>
+            <a:pPr marL="0" indent="0" algn="l">
               <a:buNone/>
             </a:pPr>
             <a:r>
@@ -7916,7 +8039,7 @@
           </a:bodyPr>
           <a:lstStyle/>
           <a:p>
-            <a:pPr algn="l" indent="0" marL="0">
+            <a:pPr marL="0" indent="0" algn="l">
               <a:buNone/>
             </a:pPr>
             <a:r>
@@ -7962,6 +8085,13 @@
             <a:prstDash val="solid"/>
           </a:ln>
         </p:spPr>
+        <p:txBody>
+          <a:bodyPr/>
+          <a:lstStyle/>
+          <a:p>
+            <a:endParaRPr lang="en-IN"/>
+          </a:p>
+        </p:txBody>
       </p:sp>
       <p:sp>
         <p:nvSpPr>
@@ -7982,11 +8112,11 @@
         </p:spPr>
         <p:txBody>
           <a:bodyPr wrap="square" lIns="0" tIns="0" rIns="0" bIns="0" rtlCol="0" anchor="ctr">
-            <a:normAutofit/>
-          </a:bodyPr>
-          <a:lstStyle/>
-          <a:p>
-            <a:pPr algn="l" indent="0" marL="0">
+            <a:normAutofit fontScale="92500" lnSpcReduction="20000"/>
+          </a:bodyPr>
+          <a:lstStyle/>
+          <a:p>
+            <a:pPr marL="0" indent="0" algn="l">
               <a:buNone/>
             </a:pPr>
             <a:r>
@@ -8023,11 +8153,11 @@
         </p:spPr>
         <p:txBody>
           <a:bodyPr wrap="square" lIns="0" tIns="0" rIns="0" bIns="0" rtlCol="0" anchor="ctr">
-            <a:normAutofit/>
-          </a:bodyPr>
-          <a:lstStyle/>
-          <a:p>
-            <a:pPr algn="l" indent="0" marL="0">
+            <a:normAutofit fontScale="92500" lnSpcReduction="20000"/>
+          </a:bodyPr>
+          <a:lstStyle/>
+          <a:p>
+            <a:pPr marL="0" indent="0" algn="l">
               <a:buNone/>
             </a:pPr>
             <a:r>
@@ -8068,7 +8198,7 @@
           </a:bodyPr>
           <a:lstStyle/>
           <a:p>
-            <a:pPr algn="l" indent="0" marL="0">
+            <a:pPr marL="0" indent="0" algn="l">
               <a:buNone/>
             </a:pPr>
             <a:r>
@@ -8114,6 +8244,13 @@
             <a:prstDash val="solid"/>
           </a:ln>
         </p:spPr>
+        <p:txBody>
+          <a:bodyPr/>
+          <a:lstStyle/>
+          <a:p>
+            <a:endParaRPr lang="en-IN"/>
+          </a:p>
+        </p:txBody>
       </p:sp>
       <p:sp>
         <p:nvSpPr>
@@ -8134,11 +8271,11 @@
         </p:spPr>
         <p:txBody>
           <a:bodyPr wrap="square" lIns="0" tIns="0" rIns="0" bIns="0" rtlCol="0" anchor="ctr">
-            <a:normAutofit/>
-          </a:bodyPr>
-          <a:lstStyle/>
-          <a:p>
-            <a:pPr algn="l" indent="0" marL="0">
+            <a:normAutofit fontScale="92500" lnSpcReduction="20000"/>
+          </a:bodyPr>
+          <a:lstStyle/>
+          <a:p>
+            <a:pPr marL="0" indent="0" algn="l">
               <a:buNone/>
             </a:pPr>
             <a:r>
@@ -8175,11 +8312,11 @@
         </p:spPr>
         <p:txBody>
           <a:bodyPr wrap="square" lIns="0" tIns="0" rIns="0" bIns="0" rtlCol="0" anchor="ctr">
-            <a:normAutofit/>
-          </a:bodyPr>
-          <a:lstStyle/>
-          <a:p>
-            <a:pPr algn="l" indent="0" marL="0">
+            <a:normAutofit fontScale="92500" lnSpcReduction="20000"/>
+          </a:bodyPr>
+          <a:lstStyle/>
+          <a:p>
+            <a:pPr marL="0" indent="0" algn="l">
               <a:buNone/>
             </a:pPr>
             <a:r>
@@ -8216,11 +8353,11 @@
         </p:spPr>
         <p:txBody>
           <a:bodyPr wrap="square" lIns="0" tIns="0" rIns="0" bIns="0" rtlCol="0" anchor="t">
-            <a:normAutofit/>
-          </a:bodyPr>
-          <a:lstStyle/>
-          <a:p>
-            <a:pPr algn="l" indent="0" marL="0">
+            <a:normAutofit fontScale="85000" lnSpcReduction="20000"/>
+          </a:bodyPr>
+          <a:lstStyle/>
+          <a:p>
+            <a:pPr marL="0" indent="0" algn="l">
               <a:buNone/>
             </a:pPr>
             <a:r>
@@ -8266,6 +8403,13 @@
             <a:prstDash val="solid"/>
           </a:ln>
         </p:spPr>
+        <p:txBody>
+          <a:bodyPr/>
+          <a:lstStyle/>
+          <a:p>
+            <a:endParaRPr lang="en-IN"/>
+          </a:p>
+        </p:txBody>
       </p:sp>
       <p:sp>
         <p:nvSpPr>
@@ -8286,11 +8430,11 @@
         </p:spPr>
         <p:txBody>
           <a:bodyPr wrap="square" lIns="0" tIns="0" rIns="0" bIns="0" rtlCol="0" anchor="ctr">
-            <a:normAutofit/>
-          </a:bodyPr>
-          <a:lstStyle/>
-          <a:p>
-            <a:pPr algn="l" indent="0" marL="0">
+            <a:normAutofit fontScale="92500" lnSpcReduction="20000"/>
+          </a:bodyPr>
+          <a:lstStyle/>
+          <a:p>
+            <a:pPr marL="0" indent="0" algn="l">
               <a:buNone/>
             </a:pPr>
             <a:r>
@@ -8327,11 +8471,11 @@
         </p:spPr>
         <p:txBody>
           <a:bodyPr wrap="square" lIns="0" tIns="0" rIns="0" bIns="0" rtlCol="0" anchor="ctr">
-            <a:normAutofit/>
-          </a:bodyPr>
-          <a:lstStyle/>
-          <a:p>
-            <a:pPr algn="l" indent="0" marL="0">
+            <a:normAutofit fontScale="92500" lnSpcReduction="20000"/>
+          </a:bodyPr>
+          <a:lstStyle/>
+          <a:p>
+            <a:pPr marL="0" indent="0" algn="l">
               <a:buNone/>
             </a:pPr>
             <a:r>
@@ -8372,7 +8516,7 @@
           </a:bodyPr>
           <a:lstStyle/>
           <a:p>
-            <a:pPr algn="l" indent="0" marL="0">
+            <a:pPr marL="0" indent="0" algn="l">
               <a:buNone/>
             </a:pPr>
             <a:r>
@@ -8418,6 +8562,13 @@
             <a:prstDash val="solid"/>
           </a:ln>
         </p:spPr>
+        <p:txBody>
+          <a:bodyPr/>
+          <a:lstStyle/>
+          <a:p>
+            <a:endParaRPr lang="en-IN"/>
+          </a:p>
+        </p:txBody>
       </p:sp>
       <p:sp>
         <p:nvSpPr>
@@ -8438,11 +8589,11 @@
         </p:spPr>
         <p:txBody>
           <a:bodyPr wrap="square" lIns="0" tIns="0" rIns="0" bIns="0" rtlCol="0" anchor="ctr">
-            <a:normAutofit/>
-          </a:bodyPr>
-          <a:lstStyle/>
-          <a:p>
-            <a:pPr algn="l" indent="0" marL="0">
+            <a:normAutofit fontScale="92500" lnSpcReduction="20000"/>
+          </a:bodyPr>
+          <a:lstStyle/>
+          <a:p>
+            <a:pPr marL="0" indent="0" algn="l">
               <a:buNone/>
             </a:pPr>
             <a:r>
@@ -8479,11 +8630,11 @@
         </p:spPr>
         <p:txBody>
           <a:bodyPr wrap="square" lIns="0" tIns="0" rIns="0" bIns="0" rtlCol="0" anchor="ctr">
-            <a:normAutofit/>
-          </a:bodyPr>
-          <a:lstStyle/>
-          <a:p>
-            <a:pPr algn="l" indent="0" marL="0">
+            <a:normAutofit fontScale="92500" lnSpcReduction="20000"/>
+          </a:bodyPr>
+          <a:lstStyle/>
+          <a:p>
+            <a:pPr marL="0" indent="0" algn="l">
               <a:buNone/>
             </a:pPr>
             <a:r>
@@ -8524,7 +8675,7 @@
           </a:bodyPr>
           <a:lstStyle/>
           <a:p>
-            <a:pPr algn="l" indent="0" marL="0">
+            <a:pPr marL="0" indent="0" algn="l">
               <a:buNone/>
             </a:pPr>
             <a:r>
@@ -8547,7 +8698,7 @@
   <p:clrMapOvr>
     <a:masterClrMapping/>
   </p:clrMapOvr>
-  <p:transition spd="med" advClick="1">
+  <p:transition spd="med">
     <p:fade/>
   </p:transition>
 </p:sld>
@@ -8561,6 +8712,7 @@
         <a:solidFill>
           <a:srgbClr val="F6F9FE"/>
         </a:solidFill>
+        <a:effectLst/>
       </p:bgPr>
     </p:bg>
     <p:spTree>
@@ -8600,7 +8752,7 @@
           </a:bodyPr>
           <a:lstStyle/>
           <a:p>
-            <a:pPr algn="l" indent="0" marL="0">
+            <a:pPr marL="0" indent="0" algn="l">
               <a:buNone/>
             </a:pPr>
             <a:r>
@@ -8637,11 +8789,11 @@
         </p:spPr>
         <p:txBody>
           <a:bodyPr wrap="square" lIns="0" tIns="0" rIns="0" bIns="0" rtlCol="0" anchor="ctr">
-            <a:normAutofit/>
-          </a:bodyPr>
-          <a:lstStyle/>
-          <a:p>
-            <a:pPr algn="l" indent="0" marL="0">
+            <a:normAutofit lnSpcReduction="10000"/>
+          </a:bodyPr>
+          <a:lstStyle/>
+          <a:p>
+            <a:pPr marL="0" indent="0" algn="l">
               <a:buNone/>
             </a:pPr>
             <a:r>
@@ -8682,7 +8834,7 @@
           </a:bodyPr>
           <a:lstStyle/>
           <a:p>
-            <a:pPr algn="l" indent="0" marL="0">
+            <a:pPr marL="0" indent="0" algn="l">
               <a:buNone/>
             </a:pPr>
             <a:r>
@@ -8723,7 +8875,7 @@
           </a:bodyPr>
           <a:lstStyle/>
           <a:p>
-            <a:pPr algn="r" indent="0" marL="0">
+            <a:pPr marL="0" indent="0" algn="r">
               <a:buNone/>
             </a:pPr>
             <a:r>
@@ -8769,6 +8921,13 @@
             <a:prstDash val="solid"/>
           </a:ln>
         </p:spPr>
+        <p:txBody>
+          <a:bodyPr/>
+          <a:lstStyle/>
+          <a:p>
+            <a:endParaRPr lang="en-IN"/>
+          </a:p>
+        </p:txBody>
       </p:sp>
       <p:sp>
         <p:nvSpPr>
@@ -8789,11 +8948,11 @@
         </p:spPr>
         <p:txBody>
           <a:bodyPr wrap="square" lIns="0" tIns="0" rIns="0" bIns="0" rtlCol="0" anchor="ctr">
-            <a:normAutofit/>
-          </a:bodyPr>
-          <a:lstStyle/>
-          <a:p>
-            <a:pPr algn="l" indent="0" marL="0">
+            <a:normAutofit fontScale="92500" lnSpcReduction="10000"/>
+          </a:bodyPr>
+          <a:lstStyle/>
+          <a:p>
+            <a:pPr marL="0" indent="0" algn="l">
               <a:buNone/>
             </a:pPr>
             <a:r>
@@ -8830,11 +8989,11 @@
         </p:spPr>
         <p:txBody>
           <a:bodyPr wrap="square" lIns="0" tIns="0" rIns="0" bIns="0" rtlCol="0" anchor="t">
-            <a:normAutofit/>
-          </a:bodyPr>
-          <a:lstStyle/>
-          <a:p>
-            <a:pPr algn="l" indent="0" marL="0">
+            <a:normAutofit fontScale="92500" lnSpcReduction="10000"/>
+          </a:bodyPr>
+          <a:lstStyle/>
+          <a:p>
+            <a:pPr marL="0" indent="0" algn="l">
               <a:buNone/>
             </a:pPr>
             <a:r>
@@ -8880,6 +9039,13 @@
             <a:prstDash val="solid"/>
           </a:ln>
         </p:spPr>
+        <p:txBody>
+          <a:bodyPr/>
+          <a:lstStyle/>
+          <a:p>
+            <a:endParaRPr lang="en-IN"/>
+          </a:p>
+        </p:txBody>
       </p:sp>
       <p:sp>
         <p:nvSpPr>
@@ -8900,11 +9066,11 @@
         </p:spPr>
         <p:txBody>
           <a:bodyPr wrap="square" lIns="0" tIns="0" rIns="0" bIns="0" rtlCol="0" anchor="ctr">
-            <a:normAutofit/>
-          </a:bodyPr>
-          <a:lstStyle/>
-          <a:p>
-            <a:pPr algn="l" indent="0" marL="0">
+            <a:normAutofit fontScale="92500" lnSpcReduction="10000"/>
+          </a:bodyPr>
+          <a:lstStyle/>
+          <a:p>
+            <a:pPr marL="0" indent="0" algn="l">
               <a:buNone/>
             </a:pPr>
             <a:r>
@@ -8945,7 +9111,7 @@
           </a:bodyPr>
           <a:lstStyle/>
           <a:p>
-            <a:pPr algn="l" indent="0" marL="0">
+            <a:pPr marL="0" indent="0" algn="l">
               <a:buNone/>
             </a:pPr>
             <a:r>
@@ -8991,6 +9157,13 @@
             <a:prstDash val="solid"/>
           </a:ln>
         </p:spPr>
+        <p:txBody>
+          <a:bodyPr/>
+          <a:lstStyle/>
+          <a:p>
+            <a:endParaRPr lang="en-IN"/>
+          </a:p>
+        </p:txBody>
       </p:sp>
       <p:sp>
         <p:nvSpPr>
@@ -9011,11 +9184,11 @@
         </p:spPr>
         <p:txBody>
           <a:bodyPr wrap="square" lIns="0" tIns="0" rIns="0" bIns="0" rtlCol="0" anchor="ctr">
-            <a:normAutofit/>
-          </a:bodyPr>
-          <a:lstStyle/>
-          <a:p>
-            <a:pPr algn="l" indent="0" marL="0">
+            <a:normAutofit fontScale="92500" lnSpcReduction="10000"/>
+          </a:bodyPr>
+          <a:lstStyle/>
+          <a:p>
+            <a:pPr marL="0" indent="0" algn="l">
               <a:buNone/>
             </a:pPr>
             <a:r>
@@ -9056,7 +9229,7 @@
           </a:bodyPr>
           <a:lstStyle/>
           <a:p>
-            <a:pPr algn="l" indent="0" marL="0">
+            <a:pPr marL="0" indent="0" algn="l">
               <a:buNone/>
             </a:pPr>
             <a:r>
@@ -9102,6 +9275,13 @@
             <a:prstDash val="solid"/>
           </a:ln>
         </p:spPr>
+        <p:txBody>
+          <a:bodyPr/>
+          <a:lstStyle/>
+          <a:p>
+            <a:endParaRPr lang="en-IN"/>
+          </a:p>
+        </p:txBody>
       </p:sp>
       <p:sp>
         <p:nvSpPr>
@@ -9122,11 +9302,11 @@
         </p:spPr>
         <p:txBody>
           <a:bodyPr wrap="square" lIns="0" tIns="0" rIns="0" bIns="0" rtlCol="0" anchor="ctr">
-            <a:normAutofit/>
-          </a:bodyPr>
-          <a:lstStyle/>
-          <a:p>
-            <a:pPr algn="l" indent="0" marL="0">
+            <a:normAutofit fontScale="92500" lnSpcReduction="10000"/>
+          </a:bodyPr>
+          <a:lstStyle/>
+          <a:p>
+            <a:pPr marL="0" indent="0" algn="l">
               <a:buNone/>
             </a:pPr>
             <a:r>
@@ -9163,11 +9343,11 @@
         </p:spPr>
         <p:txBody>
           <a:bodyPr wrap="square" lIns="0" tIns="0" rIns="0" bIns="0" rtlCol="0" anchor="t">
-            <a:normAutofit/>
-          </a:bodyPr>
-          <a:lstStyle/>
-          <a:p>
-            <a:pPr algn="l" indent="0" marL="0">
+            <a:normAutofit fontScale="92500" lnSpcReduction="10000"/>
+          </a:bodyPr>
+          <a:lstStyle/>
+          <a:p>
+            <a:pPr marL="0" indent="0" algn="l">
               <a:buNone/>
             </a:pPr>
             <a:r>
@@ -9213,6 +9393,13 @@
             <a:prstDash val="solid"/>
           </a:ln>
         </p:spPr>
+        <p:txBody>
+          <a:bodyPr/>
+          <a:lstStyle/>
+          <a:p>
+            <a:endParaRPr lang="en-IN"/>
+          </a:p>
+        </p:txBody>
       </p:sp>
       <p:sp>
         <p:nvSpPr>
@@ -9233,11 +9420,11 @@
         </p:spPr>
         <p:txBody>
           <a:bodyPr wrap="square" lIns="0" tIns="0" rIns="0" bIns="0" rtlCol="0" anchor="ctr">
-            <a:normAutofit/>
-          </a:bodyPr>
-          <a:lstStyle/>
-          <a:p>
-            <a:pPr algn="ctr" indent="0" marL="0">
+            <a:normAutofit fontScale="92500" lnSpcReduction="20000"/>
+          </a:bodyPr>
+          <a:lstStyle/>
+          <a:p>
+            <a:pPr marL="0" indent="0" algn="ctr">
               <a:buNone/>
             </a:pPr>
             <a:r>
@@ -9274,11 +9461,11 @@
         </p:spPr>
         <p:txBody>
           <a:bodyPr wrap="square" lIns="0" tIns="0" rIns="0" bIns="0" rtlCol="0" anchor="ctr">
-            <a:normAutofit/>
-          </a:bodyPr>
-          <a:lstStyle/>
-          <a:p>
-            <a:pPr algn="ctr" indent="0" marL="0">
+            <a:normAutofit fontScale="85000" lnSpcReduction="10000"/>
+          </a:bodyPr>
+          <a:lstStyle/>
+          <a:p>
+            <a:pPr marL="0" indent="0" algn="ctr">
               <a:buNone/>
             </a:pPr>
             <a:r>
@@ -9315,11 +9502,11 @@
         </p:spPr>
         <p:txBody>
           <a:bodyPr wrap="square" lIns="0" tIns="0" rIns="0" bIns="0" rtlCol="0" anchor="ctr">
-            <a:normAutofit/>
-          </a:bodyPr>
-          <a:lstStyle/>
-          <a:p>
-            <a:pPr algn="ctr" indent="0" marL="0">
+            <a:normAutofit lnSpcReduction="10000"/>
+          </a:bodyPr>
+          <a:lstStyle/>
+          <a:p>
+            <a:pPr marL="0" indent="0" algn="ctr">
               <a:buNone/>
             </a:pPr>
             <a:r>
@@ -9342,7 +9529,7 @@
   <p:clrMapOvr>
     <a:masterClrMapping/>
   </p:clrMapOvr>
-  <p:transition spd="med" advClick="1">
+  <p:transition spd="med">
     <p:fade/>
   </p:transition>
 </p:sld>
@@ -9356,6 +9543,7 @@
         <a:solidFill>
           <a:srgbClr val="0B1F3A"/>
         </a:solidFill>
+        <a:effectLst/>
       </p:bgPr>
     </p:bg>
     <p:spTree>
@@ -9395,7 +9583,7 @@
           </a:bodyPr>
           <a:lstStyle/>
           <a:p>
-            <a:pPr algn="l" indent="0" marL="0">
+            <a:pPr marL="0" indent="0" algn="l">
               <a:buNone/>
             </a:pPr>
             <a:r>
@@ -9432,11 +9620,11 @@
         </p:spPr>
         <p:txBody>
           <a:bodyPr wrap="square" lIns="0" tIns="0" rIns="0" bIns="0" rtlCol="0" anchor="ctr">
-            <a:normAutofit/>
-          </a:bodyPr>
-          <a:lstStyle/>
-          <a:p>
-            <a:pPr algn="l" indent="0" marL="0">
+            <a:normAutofit lnSpcReduction="10000"/>
+          </a:bodyPr>
+          <a:lstStyle/>
+          <a:p>
+            <a:pPr marL="0" indent="0" algn="l">
               <a:buNone/>
             </a:pPr>
             <a:r>
@@ -9477,7 +9665,7 @@
           </a:bodyPr>
           <a:lstStyle/>
           <a:p>
-            <a:pPr algn="l" indent="0" marL="0">
+            <a:pPr marL="0" indent="0" algn="l">
               <a:buNone/>
             </a:pPr>
             <a:r>
@@ -9518,7 +9706,7 @@
           </a:bodyPr>
           <a:lstStyle/>
           <a:p>
-            <a:pPr algn="r" indent="0" marL="0">
+            <a:pPr marL="0" indent="0" algn="r">
               <a:buNone/>
             </a:pPr>
             <a:r>
@@ -9564,17 +9752,24 @@
             <a:prstDash val="solid"/>
           </a:ln>
         </p:spPr>
+        <p:txBody>
+          <a:bodyPr/>
+          <a:lstStyle/>
+          <a:p>
+            <a:endParaRPr lang="en-IN"/>
+          </a:p>
+        </p:txBody>
       </p:sp>
       <p:pic>
         <p:nvPicPr>
-          <p:cNvPr id="7" name="Image 0" descr="C:\D\IIT Mumbai\Capstone Blueprint\assets\walkthrough_screens\2026_workspace_current_report.png">    </p:cNvPr>
+          <p:cNvPr id="7" name="Image 0" descr="C:\D\IIT Mumbai\Capstone Blueprint\assets\walkthrough_screens\2026_workspace_current_report.png"/>
           <p:cNvPicPr>
             <a:picLocks noChangeAspect="1"/>
           </p:cNvPicPr>
           <p:nvPr/>
         </p:nvPicPr>
         <p:blipFill>
-          <a:blip r:embed="rId1"/>
+          <a:blip r:embed="rId3"/>
           <a:stretch>
             <a:fillRect/>
           </a:stretch>
@@ -9608,11 +9803,11 @@
         </p:spPr>
         <p:txBody>
           <a:bodyPr wrap="square" lIns="0" tIns="0" rIns="0" bIns="0" rtlCol="0" anchor="ctr">
-            <a:normAutofit/>
-          </a:bodyPr>
-          <a:lstStyle/>
-          <a:p>
-            <a:pPr algn="l" indent="0" marL="0">
+            <a:normAutofit fontScale="92500" lnSpcReduction="20000"/>
+          </a:bodyPr>
+          <a:lstStyle/>
+          <a:p>
+            <a:pPr marL="0" indent="0" algn="l">
               <a:buNone/>
             </a:pPr>
             <a:r>
@@ -9653,7 +9848,7 @@
           </a:bodyPr>
           <a:lstStyle/>
           <a:p>
-            <a:pPr algn="l" indent="0" marL="0">
+            <a:pPr marL="0" indent="0" algn="l">
               <a:buNone/>
             </a:pPr>
             <a:r>
@@ -9690,11 +9885,11 @@
         </p:spPr>
         <p:txBody>
           <a:bodyPr wrap="square" lIns="0" tIns="0" rIns="0" bIns="0" rtlCol="0" anchor="ctr">
-            <a:normAutofit/>
-          </a:bodyPr>
-          <a:lstStyle/>
-          <a:p>
-            <a:pPr algn="l" indent="0" marL="0">
+            <a:normAutofit fontScale="92500" lnSpcReduction="20000"/>
+          </a:bodyPr>
+          <a:lstStyle/>
+          <a:p>
+            <a:pPr marL="0" indent="0" algn="l">
               <a:buNone/>
             </a:pPr>
             <a:r>
@@ -9735,7 +9930,7 @@
           </a:bodyPr>
           <a:lstStyle/>
           <a:p>
-            <a:pPr algn="l" indent="0" marL="0">
+            <a:pPr marL="0" indent="0" algn="l">
               <a:buNone/>
             </a:pPr>
             <a:r>
@@ -9772,11 +9967,11 @@
         </p:spPr>
         <p:txBody>
           <a:bodyPr wrap="square" lIns="0" tIns="0" rIns="0" bIns="0" rtlCol="0" anchor="ctr">
-            <a:normAutofit/>
-          </a:bodyPr>
-          <a:lstStyle/>
-          <a:p>
-            <a:pPr algn="l" indent="0" marL="0">
+            <a:normAutofit fontScale="92500" lnSpcReduction="20000"/>
+          </a:bodyPr>
+          <a:lstStyle/>
+          <a:p>
+            <a:pPr marL="0" indent="0" algn="l">
               <a:buNone/>
             </a:pPr>
             <a:r>
@@ -9817,7 +10012,7 @@
           </a:bodyPr>
           <a:lstStyle/>
           <a:p>
-            <a:pPr algn="l" indent="0" marL="0">
+            <a:pPr marL="0" indent="0" algn="l">
               <a:buNone/>
             </a:pPr>
             <a:r>
@@ -9854,11 +10049,11 @@
         </p:spPr>
         <p:txBody>
           <a:bodyPr wrap="square" lIns="0" tIns="0" rIns="0" bIns="0" rtlCol="0" anchor="t">
-            <a:normAutofit/>
-          </a:bodyPr>
-          <a:lstStyle/>
-          <a:p>
-            <a:pPr algn="l" indent="0" marL="0">
+            <a:normAutofit fontScale="77500" lnSpcReduction="20000"/>
+          </a:bodyPr>
+          <a:lstStyle/>
+          <a:p>
+            <a:pPr marL="0" indent="0" algn="l">
               <a:buNone/>
             </a:pPr>
             <a:r>
@@ -9881,7 +10076,7 @@
   <p:clrMapOvr>
     <a:masterClrMapping/>
   </p:clrMapOvr>
-  <p:transition spd="med" advClick="1">
+  <p:transition spd="med">
     <p:fade/>
   </p:transition>
 </p:sld>
@@ -10180,4 +10375,319 @@
     </a:ext>
   </a:extLst>
 </a:theme>
+</file>
+
+<file path=ppt/theme/theme2.xml><?xml version="1.0" encoding="utf-8"?>
+<a:theme xmlns:a="http://schemas.openxmlformats.org/drawingml/2006/main" name="Office Theme">
+  <a:themeElements>
+    <a:clrScheme name="Office">
+      <a:dk1>
+        <a:sysClr val="windowText" lastClr="000000"/>
+      </a:dk1>
+      <a:lt1>
+        <a:sysClr val="window" lastClr="FFFFFF"/>
+      </a:lt1>
+      <a:dk2>
+        <a:srgbClr val="0E2841"/>
+      </a:dk2>
+      <a:lt2>
+        <a:srgbClr val="E8E8E8"/>
+      </a:lt2>
+      <a:accent1>
+        <a:srgbClr val="156082"/>
+      </a:accent1>
+      <a:accent2>
+        <a:srgbClr val="E97132"/>
+      </a:accent2>
+      <a:accent3>
+        <a:srgbClr val="196B24"/>
+      </a:accent3>
+      <a:accent4>
+        <a:srgbClr val="0F9ED5"/>
+      </a:accent4>
+      <a:accent5>
+        <a:srgbClr val="A02B93"/>
+      </a:accent5>
+      <a:accent6>
+        <a:srgbClr val="4EA72E"/>
+      </a:accent6>
+      <a:hlink>
+        <a:srgbClr val="467886"/>
+      </a:hlink>
+      <a:folHlink>
+        <a:srgbClr val="96607D"/>
+      </a:folHlink>
+    </a:clrScheme>
+    <a:fontScheme name="Office">
+      <a:majorFont>
+        <a:latin typeface="Aptos Display" panose="02110004020202020204"/>
+        <a:ea typeface=""/>
+        <a:cs typeface=""/>
+        <a:font script="Jpan" typeface="游ゴシック Light"/>
+        <a:font script="Hang" typeface="맑은 고딕"/>
+        <a:font script="Hans" typeface="等线 Light"/>
+        <a:font script="Hant" typeface="新細明體"/>
+        <a:font script="Arab" typeface="Times New Roman"/>
+        <a:font script="Hebr" typeface="Times New Roman"/>
+        <a:font script="Thai" typeface="Angsana New"/>
+        <a:font script="Ethi" typeface="Nyala"/>
+        <a:font script="Beng" typeface="Vrinda"/>
+        <a:font script="Gujr" typeface="Shruti"/>
+        <a:font script="Khmr" typeface="MoolBoran"/>
+        <a:font script="Knda" typeface="Tunga"/>
+        <a:font script="Guru" typeface="Raavi"/>
+        <a:font script="Cans" typeface="Euphemia"/>
+        <a:font script="Cher" typeface="Plantagenet Cherokee"/>
+        <a:font script="Yiii" typeface="Microsoft Yi Baiti"/>
+        <a:font script="Tibt" typeface="Microsoft Himalaya"/>
+        <a:font script="Thaa" typeface="MV Boli"/>
+        <a:font script="Deva" typeface="Mangal"/>
+        <a:font script="Telu" typeface="Gautami"/>
+        <a:font script="Taml" typeface="Latha"/>
+        <a:font script="Syrc" typeface="Estrangelo Edessa"/>
+        <a:font script="Orya" typeface="Kalinga"/>
+        <a:font script="Mlym" typeface="Kartika"/>
+        <a:font script="Laoo" typeface="DokChampa"/>
+        <a:font script="Sinh" typeface="Iskoola Pota"/>
+        <a:font script="Mong" typeface="Mongolian Baiti"/>
+        <a:font script="Viet" typeface="Times New Roman"/>
+        <a:font script="Uigh" typeface="Microsoft Uighur"/>
+        <a:font script="Geor" typeface="Sylfaen"/>
+        <a:font script="Armn" typeface="Arial"/>
+        <a:font script="Bugi" typeface="Leelawadee UI"/>
+        <a:font script="Bopo" typeface="Microsoft JhengHei"/>
+        <a:font script="Java" typeface="Javanese Text"/>
+        <a:font script="Lisu" typeface="Segoe UI"/>
+        <a:font script="Mymr" typeface="Myanmar Text"/>
+        <a:font script="Nkoo" typeface="Ebrima"/>
+        <a:font script="Olck" typeface="Nirmala UI"/>
+        <a:font script="Osma" typeface="Ebrima"/>
+        <a:font script="Phag" typeface="Phagspa"/>
+        <a:font script="Syrn" typeface="Estrangelo Edessa"/>
+        <a:font script="Syrj" typeface="Estrangelo Edessa"/>
+        <a:font script="Syre" typeface="Estrangelo Edessa"/>
+        <a:font script="Sora" typeface="Nirmala UI"/>
+        <a:font script="Tale" typeface="Microsoft Tai Le"/>
+        <a:font script="Talu" typeface="Microsoft New Tai Lue"/>
+        <a:font script="Tfng" typeface="Ebrima"/>
+      </a:majorFont>
+      <a:minorFont>
+        <a:latin typeface="Aptos" panose="02110004020202020204"/>
+        <a:ea typeface=""/>
+        <a:cs typeface=""/>
+        <a:font script="Jpan" typeface="游ゴシック"/>
+        <a:font script="Hang" typeface="맑은 고딕"/>
+        <a:font script="Hans" typeface="等线"/>
+        <a:font script="Hant" typeface="新細明體"/>
+        <a:font script="Arab" typeface="Arial"/>
+        <a:font script="Hebr" typeface="Arial"/>
+        <a:font script="Thai" typeface="Cordia New"/>
+        <a:font script="Ethi" typeface="Nyala"/>
+        <a:font script="Beng" typeface="Vrinda"/>
+        <a:font script="Gujr" typeface="Shruti"/>
+        <a:font script="Khmr" typeface="DaunPenh"/>
+        <a:font script="Knda" typeface="Tunga"/>
+        <a:font script="Guru" typeface="Raavi"/>
+        <a:font script="Cans" typeface="Euphemia"/>
+        <a:font script="Cher" typeface="Plantagenet Cherokee"/>
+        <a:font script="Yiii" typeface="Microsoft Yi Baiti"/>
+        <a:font script="Tibt" typeface="Microsoft Himalaya"/>
+        <a:font script="Thaa" typeface="MV Boli"/>
+        <a:font script="Deva" typeface="Mangal"/>
+        <a:font script="Telu" typeface="Gautami"/>
+        <a:font script="Taml" typeface="Latha"/>
+        <a:font script="Syrc" typeface="Estrangelo Edessa"/>
+        <a:font script="Orya" typeface="Kalinga"/>
+        <a:font script="Mlym" typeface="Kartika"/>
+        <a:font script="Laoo" typeface="DokChampa"/>
+        <a:font script="Sinh" typeface="Iskoola Pota"/>
+        <a:font script="Mong" typeface="Mongolian Baiti"/>
+        <a:font script="Viet" typeface="Arial"/>
+        <a:font script="Uigh" typeface="Microsoft Uighur"/>
+        <a:font script="Geor" typeface="Sylfaen"/>
+        <a:font script="Armn" typeface="Arial"/>
+        <a:font script="Bugi" typeface="Leelawadee UI"/>
+        <a:font script="Bopo" typeface="Microsoft JhengHei"/>
+        <a:font script="Java" typeface="Javanese Text"/>
+        <a:font script="Lisu" typeface="Segoe UI"/>
+        <a:font script="Mymr" typeface="Myanmar Text"/>
+        <a:font script="Nkoo" typeface="Ebrima"/>
+        <a:font script="Olck" typeface="Nirmala UI"/>
+        <a:font script="Osma" typeface="Ebrima"/>
+        <a:font script="Phag" typeface="Phagspa"/>
+        <a:font script="Syrn" typeface="Estrangelo Edessa"/>
+        <a:font script="Syrj" typeface="Estrangelo Edessa"/>
+        <a:font script="Syre" typeface="Estrangelo Edessa"/>
+        <a:font script="Sora" typeface="Nirmala UI"/>
+        <a:font script="Tale" typeface="Microsoft Tai Le"/>
+        <a:font script="Talu" typeface="Microsoft New Tai Lue"/>
+        <a:font script="Tfng" typeface="Ebrima"/>
+      </a:minorFont>
+    </a:fontScheme>
+    <a:fmtScheme name="Office">
+      <a:fillStyleLst>
+        <a:solidFill>
+          <a:schemeClr val="phClr"/>
+        </a:solidFill>
+        <a:gradFill rotWithShape="1">
+          <a:gsLst>
+            <a:gs pos="0">
+              <a:schemeClr val="phClr">
+                <a:lumMod val="110000"/>
+                <a:satMod val="105000"/>
+                <a:tint val="67000"/>
+              </a:schemeClr>
+            </a:gs>
+            <a:gs pos="50000">
+              <a:schemeClr val="phClr">
+                <a:lumMod val="105000"/>
+                <a:satMod val="103000"/>
+                <a:tint val="73000"/>
+              </a:schemeClr>
+            </a:gs>
+            <a:gs pos="100000">
+              <a:schemeClr val="phClr">
+                <a:lumMod val="105000"/>
+                <a:satMod val="109000"/>
+                <a:tint val="81000"/>
+              </a:schemeClr>
+            </a:gs>
+          </a:gsLst>
+          <a:lin ang="5400000" scaled="0"/>
+        </a:gradFill>
+        <a:gradFill rotWithShape="1">
+          <a:gsLst>
+            <a:gs pos="0">
+              <a:schemeClr val="phClr">
+                <a:satMod val="103000"/>
+                <a:lumMod val="102000"/>
+                <a:tint val="94000"/>
+              </a:schemeClr>
+            </a:gs>
+            <a:gs pos="50000">
+              <a:schemeClr val="phClr">
+                <a:satMod val="110000"/>
+                <a:lumMod val="100000"/>
+                <a:shade val="100000"/>
+              </a:schemeClr>
+            </a:gs>
+            <a:gs pos="100000">
+              <a:schemeClr val="phClr">
+                <a:lumMod val="99000"/>
+                <a:satMod val="120000"/>
+                <a:shade val="78000"/>
+              </a:schemeClr>
+            </a:gs>
+          </a:gsLst>
+          <a:lin ang="5400000" scaled="0"/>
+        </a:gradFill>
+      </a:fillStyleLst>
+      <a:lnStyleLst>
+        <a:ln w="12700" cap="flat" cmpd="sng" algn="ctr">
+          <a:solidFill>
+            <a:schemeClr val="phClr"/>
+          </a:solidFill>
+          <a:prstDash val="solid"/>
+          <a:miter lim="800000"/>
+        </a:ln>
+        <a:ln w="19050" cap="flat" cmpd="sng" algn="ctr">
+          <a:solidFill>
+            <a:schemeClr val="phClr"/>
+          </a:solidFill>
+          <a:prstDash val="solid"/>
+          <a:miter lim="800000"/>
+        </a:ln>
+        <a:ln w="25400" cap="flat" cmpd="sng" algn="ctr">
+          <a:solidFill>
+            <a:schemeClr val="phClr"/>
+          </a:solidFill>
+          <a:prstDash val="solid"/>
+          <a:miter lim="800000"/>
+        </a:ln>
+      </a:lnStyleLst>
+      <a:effectStyleLst>
+        <a:effectStyle>
+          <a:effectLst/>
+        </a:effectStyle>
+        <a:effectStyle>
+          <a:effectLst/>
+        </a:effectStyle>
+        <a:effectStyle>
+          <a:effectLst>
+            <a:outerShdw blurRad="57150" dist="19050" dir="5400000" algn="ctr" rotWithShape="0">
+              <a:srgbClr val="000000">
+                <a:alpha val="63000"/>
+              </a:srgbClr>
+            </a:outerShdw>
+          </a:effectLst>
+        </a:effectStyle>
+      </a:effectStyleLst>
+      <a:bgFillStyleLst>
+        <a:solidFill>
+          <a:schemeClr val="phClr"/>
+        </a:solidFill>
+        <a:solidFill>
+          <a:schemeClr val="phClr">
+            <a:tint val="95000"/>
+            <a:satMod val="170000"/>
+          </a:schemeClr>
+        </a:solidFill>
+        <a:gradFill rotWithShape="1">
+          <a:gsLst>
+            <a:gs pos="0">
+              <a:schemeClr val="phClr">
+                <a:tint val="93000"/>
+                <a:satMod val="150000"/>
+                <a:shade val="98000"/>
+                <a:lumMod val="102000"/>
+              </a:schemeClr>
+            </a:gs>
+            <a:gs pos="50000">
+              <a:schemeClr val="phClr">
+                <a:tint val="98000"/>
+                <a:satMod val="130000"/>
+                <a:shade val="90000"/>
+                <a:lumMod val="103000"/>
+              </a:schemeClr>
+            </a:gs>
+            <a:gs pos="100000">
+              <a:schemeClr val="phClr">
+                <a:shade val="63000"/>
+                <a:satMod val="120000"/>
+              </a:schemeClr>
+            </a:gs>
+          </a:gsLst>
+          <a:lin ang="5400000" scaled="0"/>
+        </a:gradFill>
+      </a:bgFillStyleLst>
+    </a:fmtScheme>
+  </a:themeElements>
+  <a:objectDefaults>
+    <a:lnDef>
+      <a:spPr/>
+      <a:bodyPr/>
+      <a:lstStyle/>
+      <a:style>
+        <a:lnRef idx="2">
+          <a:schemeClr val="accent1"/>
+        </a:lnRef>
+        <a:fillRef idx="0">
+          <a:schemeClr val="accent1"/>
+        </a:fillRef>
+        <a:effectRef idx="1">
+          <a:schemeClr val="accent1"/>
+        </a:effectRef>
+        <a:fontRef idx="minor">
+          <a:schemeClr val="tx1"/>
+        </a:fontRef>
+      </a:style>
+    </a:lnDef>
+  </a:objectDefaults>
+  <a:extraClrSchemeLst/>
+  <a:extLst>
+    <a:ext uri="{05A4C25C-085E-4340-85A3-A5531E510DB2}">
+      <thm15:themeFamily xmlns:thm15="http://schemas.microsoft.com/office/thememl/2012/main" name="Office Theme" id="{2E142A2C-CD16-42D6-873A-C26D2A0506FA}" vid="{1BDDFF52-6CD6-40A5-AB3C-68EB2F1E4D0A}"/>
+    </a:ext>
+  </a:extLst>
+</a:theme>
 </file>
</xml_diff>